<commit_message>
Apresentação: slide da retirada automática de peça capturada
- Novo slide s11 (captura automática): problema, solução (@sync) e
  pontos de sincronização
- s07 (IPC): bloco mono do canal de volta @sync|... e menção no cartão
  do teclado
- s13 (testes): 5 suítes (inclui test_keypad_capture.py), evidências
  atualizadas
- s14 (rastreabilidade): RNF3 cita espelho bidirecional
- s15 (dificuldades): divergência resolvida com canal @sync
- s16 (considerações finais): menciona o fechamento do atrito de
  usabilidade do teclado
- 17 slides (antes 16)
</commit_message>
<xml_diff>
--- a/docs/Apresentacao-Final.pptx
+++ b/docs/Apresentacao-Final.pptx
@@ -21,6 +21,7 @@
     <p:sldId id="269" r:id="rId20"/>
     <p:sldId id="270" r:id="rId21"/>
     <p:sldId id="271" r:id="rId22"/>
+    <p:sldId id="272" r:id="rId23"/>
   </p:sldIdLst>
   <p:sldSz cx="12191695" cy="6858000" type="screen4x3"/>
   <p:notesSz cx="6858000" cy="9144000"/>
@@ -6636,58 +6637,14 @@
       </p:sp>
       <p:sp>
         <p:nvSpPr>
-          <p:cNvPr id="3" name="Rectangle 2"/>
-          <p:cNvSpPr/>
-          <p:nvPr/>
-        </p:nvSpPr>
-        <p:spPr>
-          <a:xfrm>
-            <a:off x="0" y="0"/>
-            <a:ext cx="201168" cy="6858000"/>
-          </a:xfrm>
-          <a:prstGeom prst="rect">
-            <a:avLst/>
-          </a:prstGeom>
-          <a:solidFill>
-            <a:srgbClr val="E2B714"/>
-          </a:solidFill>
-          <a:ln>
-            <a:noFill/>
-          </a:ln>
-          <a:effectLst/>
-        </p:spPr>
-        <p:style>
-          <a:lnRef idx="1">
-            <a:schemeClr val="accent1"/>
-          </a:lnRef>
-          <a:fillRef idx="3">
-            <a:schemeClr val="accent1"/>
-          </a:fillRef>
-          <a:effectRef idx="2">
-            <a:schemeClr val="accent1"/>
-          </a:effectRef>
-          <a:fontRef idx="minor">
-            <a:schemeClr val="lt1"/>
-          </a:fontRef>
-        </p:style>
-        <p:txBody>
-          <a:bodyPr rtlCol="0" anchor="ctr"/>
-          <a:lstStyle/>
-          <a:p>
-            <a:pPr algn="ctr"/>
-          </a:p>
-        </p:txBody>
-      </p:sp>
-      <p:sp>
-        <p:nvSpPr>
-          <p:cNvPr id="4" name="TextBox 3"/>
+          <p:cNvPr id="3" name="TextBox 2"/>
           <p:cNvSpPr txBox="1"/>
           <p:nvPr/>
         </p:nvSpPr>
         <p:spPr>
           <a:xfrm>
-            <a:off x="1005840" y="2103120"/>
-            <a:ext cx="10058400" cy="2743200"/>
+            <a:off x="685800" y="411480"/>
+            <a:ext cx="10820095" cy="914400"/>
           </a:xfrm>
           <a:prstGeom prst="rect">
             <a:avLst/>
@@ -6702,46 +6659,385 @@
           <a:p>
             <a:pPr algn="l">
               <a:spcAft>
-                <a:spcPts val="1600"/>
-              </a:spcAft>
-            </a:pPr>
-            <a:r>
-              <a:rPr sz="1600" b="1">
+                <a:spcPts val="200"/>
+              </a:spcAft>
+            </a:pPr>
+            <a:r>
+              <a:rPr sz="3200" b="1">
+                <a:solidFill>
+                  <a:srgbClr val="F2F4F8"/>
+                </a:solidFill>
+              </a:rPr>
+              <a:t>Retirada automática de peça capturada</a:t>
+            </a:r>
+          </a:p>
+          <a:p>
+            <a:pPr algn="l">
+              <a:spcAft>
+                <a:spcPts val="0"/>
+              </a:spcAft>
+            </a:pPr>
+            <a:r>
+              <a:rPr sz="1500" b="0">
+                <a:solidFill>
+                  <a:srgbClr val="9FB3C8"/>
+                </a:solidFill>
+              </a:rPr>
+              <a:t>Eliminando o passo manual que travava o teclado</a:t>
+            </a:r>
+          </a:p>
+        </p:txBody>
+      </p:sp>
+      <p:sp>
+        <p:nvSpPr>
+          <p:cNvPr id="4" name="Rectangle 3"/>
+          <p:cNvSpPr/>
+          <p:nvPr/>
+        </p:nvSpPr>
+        <p:spPr>
+          <a:xfrm>
+            <a:off x="685800" y="1298448"/>
+            <a:ext cx="1371600" cy="38100"/>
+          </a:xfrm>
+          <a:prstGeom prst="rect">
+            <a:avLst/>
+          </a:prstGeom>
+          <a:solidFill>
+            <a:srgbClr val="E2B714"/>
+          </a:solidFill>
+          <a:ln>
+            <a:noFill/>
+          </a:ln>
+          <a:effectLst/>
+        </p:spPr>
+        <p:style>
+          <a:lnRef idx="1">
+            <a:schemeClr val="accent1"/>
+          </a:lnRef>
+          <a:fillRef idx="3">
+            <a:schemeClr val="accent1"/>
+          </a:fillRef>
+          <a:effectRef idx="2">
+            <a:schemeClr val="accent1"/>
+          </a:effectRef>
+          <a:fontRef idx="minor">
+            <a:schemeClr val="lt1"/>
+          </a:fontRef>
+        </p:style>
+        <p:txBody>
+          <a:bodyPr rtlCol="0" anchor="ctr"/>
+          <a:lstStyle/>
+          <a:p>
+            <a:pPr algn="ctr"/>
+          </a:p>
+        </p:txBody>
+      </p:sp>
+      <p:sp>
+        <p:nvSpPr>
+          <p:cNvPr id="5" name="Rounded Rectangle 4"/>
+          <p:cNvSpPr/>
+          <p:nvPr/>
+        </p:nvSpPr>
+        <p:spPr>
+          <a:xfrm>
+            <a:off x="685800" y="1783080"/>
+            <a:ext cx="5349240" cy="2103120"/>
+          </a:xfrm>
+          <a:prstGeom prst="roundRect">
+            <a:avLst>
+              <a:gd name="adj" fmla="val 6000"/>
+            </a:avLst>
+          </a:prstGeom>
+          <a:solidFill>
+            <a:srgbClr val="172740"/>
+          </a:solidFill>
+          <a:ln w="15875">
+            <a:solidFill>
+              <a:srgbClr val="E94560"/>
+            </a:solidFill>
+          </a:ln>
+          <a:effectLst/>
+        </p:spPr>
+        <p:style>
+          <a:lnRef idx="1">
+            <a:schemeClr val="accent1"/>
+          </a:lnRef>
+          <a:fillRef idx="3">
+            <a:schemeClr val="accent1"/>
+          </a:fillRef>
+          <a:effectRef idx="2">
+            <a:schemeClr val="accent1"/>
+          </a:effectRef>
+          <a:fontRef idx="minor">
+            <a:schemeClr val="lt1"/>
+          </a:fontRef>
+        </p:style>
+        <p:txBody>
+          <a:bodyPr rtlCol="0" anchor="t" wrap="square" lIns="201168" rIns="201168" tIns="164592" bIns="164592"/>
+          <a:lstStyle/>
+          <a:p>
+            <a:pPr algn="l">
+              <a:spcAft>
+                <a:spcPts val="600"/>
+              </a:spcAft>
+            </a:pPr>
+            <a:r>
+              <a:rPr sz="1700" b="1">
+                <a:solidFill>
+                  <a:srgbClr val="E94560"/>
+                </a:solidFill>
+              </a:rPr>
+              <a:t>O problema</a:t>
+            </a:r>
+          </a:p>
+          <a:p>
+            <a:pPr algn="l">
+              <a:spcAft>
+                <a:spcPts val="400"/>
+              </a:spcAft>
+            </a:pPr>
+            <a:r>
+              <a:rPr sz="1300" b="0">
+                <a:solidFill>
+                  <a:srgbClr val="D6DEE8"/>
+                </a:solidFill>
+              </a:rPr>
+              <a:t>Quando o oponente captura uma peça do jogador, a peça sai do tabuleiro virtual mas fica no espelho da camada C.</a:t>
+            </a:r>
+          </a:p>
+          <a:p>
+            <a:pPr algn="l">
+              <a:spcAft>
+                <a:spcPts val="400"/>
+              </a:spcAft>
+            </a:pPr>
+            <a:r>
+              <a:rPr sz="1300" b="0">
+                <a:solidFill>
+                  <a:srgbClr val="D6DEE8"/>
+                </a:solidFill>
+              </a:rPr>
+              <a:t>Até aqui, o jogador precisava digitar  0 1 &lt;casa&gt; #  para corrigir o espelho antes de poder jogar — inclusive antes de recapturar.</a:t>
+            </a:r>
+          </a:p>
+        </p:txBody>
+      </p:sp>
+      <p:sp>
+        <p:nvSpPr>
+          <p:cNvPr id="6" name="Rounded Rectangle 5"/>
+          <p:cNvSpPr/>
+          <p:nvPr/>
+        </p:nvSpPr>
+        <p:spPr>
+          <a:xfrm>
+            <a:off x="6492240" y="1783080"/>
+            <a:ext cx="5349240" cy="2103120"/>
+          </a:xfrm>
+          <a:prstGeom prst="roundRect">
+            <a:avLst>
+              <a:gd name="adj" fmla="val 6000"/>
+            </a:avLst>
+          </a:prstGeom>
+          <a:solidFill>
+            <a:srgbClr val="172740"/>
+          </a:solidFill>
+          <a:ln w="15875">
+            <a:solidFill>
+              <a:srgbClr val="4CC38A"/>
+            </a:solidFill>
+          </a:ln>
+          <a:effectLst/>
+        </p:spPr>
+        <p:style>
+          <a:lnRef idx="1">
+            <a:schemeClr val="accent1"/>
+          </a:lnRef>
+          <a:fillRef idx="3">
+            <a:schemeClr val="accent1"/>
+          </a:fillRef>
+          <a:effectRef idx="2">
+            <a:schemeClr val="accent1"/>
+          </a:effectRef>
+          <a:fontRef idx="minor">
+            <a:schemeClr val="lt1"/>
+          </a:fontRef>
+        </p:style>
+        <p:txBody>
+          <a:bodyPr rtlCol="0" anchor="t" wrap="square" lIns="201168" rIns="201168" tIns="164592" bIns="164592"/>
+          <a:lstStyle/>
+          <a:p>
+            <a:pPr algn="l">
+              <a:spcAft>
+                <a:spcPts val="600"/>
+              </a:spcAft>
+            </a:pPr>
+            <a:r>
+              <a:rPr sz="1700" b="1">
+                <a:solidFill>
+                  <a:srgbClr val="4CC38A"/>
+                </a:solidFill>
+              </a:rPr>
+              <a:t>A solução</a:t>
+            </a:r>
+          </a:p>
+          <a:p>
+            <a:pPr algn="l">
+              <a:spcAft>
+                <a:spcPts val="400"/>
+              </a:spcAft>
+            </a:pPr>
+            <a:r>
+              <a:rPr sz="1300" b="0">
+                <a:solidFill>
+                  <a:srgbClr val="D6DEE8"/>
+                </a:solidFill>
+              </a:rPr>
+              <a:t>Canal de volta Python → C por stdin: a aplicação manda @sync|&lt;64 chars '0'/'1'&gt; com o espelho dela.</a:t>
+            </a:r>
+          </a:p>
+          <a:p>
+            <a:pPr algn="l">
+              <a:spcAft>
+                <a:spcPts val="400"/>
+              </a:spcAft>
+            </a:pPr>
+            <a:r>
+              <a:rPr sz="1300" b="0">
+                <a:solidFill>
+                  <a:srgbClr val="D6DEE8"/>
+                </a:solidFill>
+              </a:rPr>
+              <a:t>A camada C adota o espelho, e o LCD mostra qual peça retirar da mesa — sem bloquear o jogo.</a:t>
+            </a:r>
+          </a:p>
+        </p:txBody>
+      </p:sp>
+      <p:sp>
+        <p:nvSpPr>
+          <p:cNvPr id="7" name="TextBox 6"/>
+          <p:cNvSpPr txBox="1"/>
+          <p:nvPr/>
+        </p:nvSpPr>
+        <p:spPr>
+          <a:xfrm>
+            <a:off x="685800" y="4160520"/>
+            <a:ext cx="10820095" cy="2103120"/>
+          </a:xfrm>
+          <a:prstGeom prst="rect">
+            <a:avLst/>
+          </a:prstGeom>
+          <a:noFill/>
+        </p:spPr>
+        <p:txBody>
+          <a:bodyPr wrap="square" lIns="0" rIns="0" tIns="0" bIns="0">
+            <a:spAutoFit/>
+          </a:bodyPr>
+          <a:lstStyle/>
+          <a:p>
+            <a:pPr algn="l">
+              <a:spcAft>
+                <a:spcPts val="1000"/>
+              </a:spcAft>
+            </a:pPr>
+            <a:r>
+              <a:rPr sz="1900" b="1">
+                <a:solidFill>
+                  <a:srgbClr val="F2F4F8"/>
+                </a:solidFill>
+              </a:rPr>
+              <a:t>Onde a sincronização acontece</a:t>
+            </a:r>
+          </a:p>
+          <a:p>
+            <a:pPr algn="l">
+              <a:spcAft>
+                <a:spcPts val="500"/>
+              </a:spcAft>
+            </a:pPr>
+            <a:r>
+              <a:rPr sz="1400" b="1">
                 <a:solidFill>
                   <a:srgbClr val="E2B714"/>
                 </a:solidFill>
               </a:rPr>
-              <a:t>DEMONSTRAÇÃO</a:t>
-            </a:r>
-          </a:p>
-          <a:p>
-            <a:pPr algn="l">
-              <a:spcAft>
-                <a:spcPts val="2400"/>
-              </a:spcAft>
-            </a:pPr>
-            <a:r>
-              <a:rPr sz="4000" b="1">
-                <a:solidFill>
-                  <a:srgbClr val="F2F4F8"/>
-                </a:solidFill>
-              </a:rPr>
-              <a:t>O funcionamento será mostrado ao vivo</a:t>
-            </a:r>
-          </a:p>
-          <a:p>
-            <a:pPr algn="l">
-              <a:spcAft>
-                <a:spcPts val="0"/>
-              </a:spcAft>
-            </a:pPr>
-            <a:r>
-              <a:rPr sz="1700" b="0">
+              <a:t>▸  </a:t>
+            </a:r>
+            <a:r>
+              <a:rPr sz="1400" b="0">
                 <a:solidFill>
                   <a:srgbClr val="D6DEE8"/>
                 </a:solidFill>
               </a:rPr>
-              <a:t>Partida contra o Stockfish pelo teclado matricial  ·  partida online via Lichess  ·  mock gráfico dos reed switches  ·  fileiras montadas do tabuleiro</a:t>
+              <a:t>Após todo lance aplicado (_push_mirror_to_hardware): mantém a invariante de que os dois espelhos são iguais.</a:t>
+            </a:r>
+          </a:p>
+          <a:p>
+            <a:pPr algn="l">
+              <a:spcAft>
+                <a:spcPts val="500"/>
+              </a:spcAft>
+            </a:pPr>
+            <a:r>
+              <a:rPr sz="1400" b="1">
+                <a:solidFill>
+                  <a:srgbClr val="E2B714"/>
+                </a:solidFill>
+              </a:rPr>
+              <a:t>▸  </a:t>
+            </a:r>
+            <a:r>
+              <a:rPr sz="1400" b="0">
+                <a:solidFill>
+                  <a:srgbClr val="D6DEE8"/>
+                </a:solidFill>
+              </a:rPr>
+              <a:t>Após lance do oponente (_absorb_captured_pieces): esvazia do espelho Python as casas capturadas e reenvia ao C.</a:t>
+            </a:r>
+          </a:p>
+          <a:p>
+            <a:pPr algn="l">
+              <a:spcAft>
+                <a:spcPts val="500"/>
+              </a:spcAft>
+            </a:pPr>
+            <a:r>
+              <a:rPr sz="1400" b="1">
+                <a:solidFill>
+                  <a:srgbClr val="E2B714"/>
+                </a:solidFill>
+              </a:rPr>
+              <a:t>▸  </a:t>
+            </a:r>
+            <a:r>
+              <a:rPr sz="1400" b="0">
+                <a:solidFill>
+                  <a:srgbClr val="D6DEE8"/>
+                </a:solidFill>
+              </a:rPr>
+              <a:t>Na reinicialização e troca de cor: o processo C nasceu com um espelho que pode não ser mais o certo.</a:t>
+            </a:r>
+          </a:p>
+          <a:p>
+            <a:pPr algn="l">
+              <a:spcAft>
+                <a:spcPts val="500"/>
+              </a:spcAft>
+            </a:pPr>
+            <a:r>
+              <a:rPr sz="1400" b="1">
+                <a:solidFill>
+                  <a:srgbClr val="E2B714"/>
+                </a:solidFill>
+              </a:rPr>
+              <a:t>▸  </a:t>
+            </a:r>
+            <a:r>
+              <a:rPr sz="1400" b="0">
+                <a:solidFill>
+                  <a:srgbClr val="D6DEE8"/>
+                </a:solidFill>
+              </a:rPr>
+              <a:t>Só no teclado GPIO: reed switches leem o tabuleiro de verdade, e o mock tem tabuleiro próprio.</a:t>
             </a:r>
           </a:p>
         </p:txBody>
@@ -6810,14 +7106,58 @@
       </p:sp>
       <p:sp>
         <p:nvSpPr>
-          <p:cNvPr id="3" name="TextBox 2"/>
+          <p:cNvPr id="3" name="Rectangle 2"/>
+          <p:cNvSpPr/>
+          <p:nvPr/>
+        </p:nvSpPr>
+        <p:spPr>
+          <a:xfrm>
+            <a:off x="0" y="0"/>
+            <a:ext cx="201168" cy="6858000"/>
+          </a:xfrm>
+          <a:prstGeom prst="rect">
+            <a:avLst/>
+          </a:prstGeom>
+          <a:solidFill>
+            <a:srgbClr val="E2B714"/>
+          </a:solidFill>
+          <a:ln>
+            <a:noFill/>
+          </a:ln>
+          <a:effectLst/>
+        </p:spPr>
+        <p:style>
+          <a:lnRef idx="1">
+            <a:schemeClr val="accent1"/>
+          </a:lnRef>
+          <a:fillRef idx="3">
+            <a:schemeClr val="accent1"/>
+          </a:fillRef>
+          <a:effectRef idx="2">
+            <a:schemeClr val="accent1"/>
+          </a:effectRef>
+          <a:fontRef idx="minor">
+            <a:schemeClr val="lt1"/>
+          </a:fontRef>
+        </p:style>
+        <p:txBody>
+          <a:bodyPr rtlCol="0" anchor="ctr"/>
+          <a:lstStyle/>
+          <a:p>
+            <a:pPr algn="ctr"/>
+          </a:p>
+        </p:txBody>
+      </p:sp>
+      <p:sp>
+        <p:nvSpPr>
+          <p:cNvPr id="4" name="TextBox 3"/>
           <p:cNvSpPr txBox="1"/>
           <p:nvPr/>
         </p:nvSpPr>
         <p:spPr>
           <a:xfrm>
-            <a:off x="685800" y="411480"/>
-            <a:ext cx="10820095" cy="914400"/>
+            <a:off x="1005840" y="2103120"/>
+            <a:ext cx="10058400" cy="2743200"/>
           </a:xfrm>
           <a:prstGeom prst="rect">
             <a:avLst/>
@@ -6832,16 +7172,31 @@
           <a:p>
             <a:pPr algn="l">
               <a:spcAft>
-                <a:spcPts val="200"/>
-              </a:spcAft>
-            </a:pPr>
-            <a:r>
-              <a:rPr sz="3200" b="1">
+                <a:spcPts val="1600"/>
+              </a:spcAft>
+            </a:pPr>
+            <a:r>
+              <a:rPr sz="1600" b="1">
+                <a:solidFill>
+                  <a:srgbClr val="E2B714"/>
+                </a:solidFill>
+              </a:rPr>
+              <a:t>DEMONSTRAÇÃO</a:t>
+            </a:r>
+          </a:p>
+          <a:p>
+            <a:pPr algn="l">
+              <a:spcAft>
+                <a:spcPts val="2400"/>
+              </a:spcAft>
+            </a:pPr>
+            <a:r>
+              <a:rPr sz="4000" b="1">
                 <a:solidFill>
                   <a:srgbClr val="F2F4F8"/>
                 </a:solidFill>
               </a:rPr>
-              <a:t>Testes realizados</a:t>
+              <a:t>O funcionamento será mostrado ao vivo</a:t>
             </a:r>
           </a:p>
           <a:p>
@@ -6851,386 +7206,12 @@
               </a:spcAft>
             </a:pPr>
             <a:r>
-              <a:rPr sz="1500" b="0">
-                <a:solidFill>
-                  <a:srgbClr val="9FB3C8"/>
-                </a:solidFill>
-              </a:rPr>
-              <a:t>Quatro suítes automatizadas, sem depender de token, rede, Stockfish ou display</a:t>
-            </a:r>
-          </a:p>
-        </p:txBody>
-      </p:sp>
-      <p:sp>
-        <p:nvSpPr>
-          <p:cNvPr id="4" name="Rectangle 3"/>
-          <p:cNvSpPr/>
-          <p:nvPr/>
-        </p:nvSpPr>
-        <p:spPr>
-          <a:xfrm>
-            <a:off x="685800" y="1298448"/>
-            <a:ext cx="1371600" cy="38100"/>
-          </a:xfrm>
-          <a:prstGeom prst="rect">
-            <a:avLst/>
-          </a:prstGeom>
-          <a:solidFill>
-            <a:srgbClr val="E2B714"/>
-          </a:solidFill>
-          <a:ln>
-            <a:noFill/>
-          </a:ln>
-          <a:effectLst/>
-        </p:spPr>
-        <p:style>
-          <a:lnRef idx="1">
-            <a:schemeClr val="accent1"/>
-          </a:lnRef>
-          <a:fillRef idx="3">
-            <a:schemeClr val="accent1"/>
-          </a:fillRef>
-          <a:effectRef idx="2">
-            <a:schemeClr val="accent1"/>
-          </a:effectRef>
-          <a:fontRef idx="minor">
-            <a:schemeClr val="lt1"/>
-          </a:fontRef>
-        </p:style>
-        <p:txBody>
-          <a:bodyPr rtlCol="0" anchor="ctr"/>
-          <a:lstStyle/>
-          <a:p>
-            <a:pPr algn="ctr"/>
-          </a:p>
-        </p:txBody>
-      </p:sp>
-      <p:sp>
-        <p:nvSpPr>
-          <p:cNvPr id="5" name="Rounded Rectangle 4"/>
-          <p:cNvSpPr/>
-          <p:nvPr/>
-        </p:nvSpPr>
-        <p:spPr>
-          <a:xfrm>
-            <a:off x="685800" y="1783080"/>
-            <a:ext cx="5349240" cy="2514600"/>
-          </a:xfrm>
-          <a:prstGeom prst="roundRect">
-            <a:avLst>
-              <a:gd name="adj" fmla="val 6000"/>
-            </a:avLst>
-          </a:prstGeom>
-          <a:solidFill>
-            <a:srgbClr val="172740"/>
-          </a:solidFill>
-          <a:ln w="15875">
-            <a:solidFill>
-              <a:srgbClr val="4CC38A"/>
-            </a:solidFill>
-          </a:ln>
-          <a:effectLst/>
-        </p:spPr>
-        <p:style>
-          <a:lnRef idx="1">
-            <a:schemeClr val="accent1"/>
-          </a:lnRef>
-          <a:fillRef idx="3">
-            <a:schemeClr val="accent1"/>
-          </a:fillRef>
-          <a:effectRef idx="2">
-            <a:schemeClr val="accent1"/>
-          </a:effectRef>
-          <a:fontRef idx="minor">
-            <a:schemeClr val="lt1"/>
-          </a:fontRef>
-        </p:style>
-        <p:txBody>
-          <a:bodyPr rtlCol="0" anchor="t" wrap="square" lIns="201168" rIns="201168" tIns="164592" bIns="164592"/>
-          <a:lstStyle/>
-          <a:p>
-            <a:pPr algn="l">
-              <a:spcAft>
-                <a:spcPts val="600"/>
-              </a:spcAft>
-            </a:pPr>
-            <a:r>
-              <a:rPr sz="1700" b="1">
-                <a:solidFill>
-                  <a:srgbClr val="4CC38A"/>
-                </a:solidFill>
-              </a:rPr>
-              <a:t>Suítes  (make test)</a:t>
-            </a:r>
-          </a:p>
-          <a:p>
-            <a:pPr algn="l">
-              <a:spcAft>
-                <a:spcPts val="400"/>
-              </a:spcAft>
-            </a:pPr>
-            <a:r>
-              <a:rPr sz="1300" b="0">
+              <a:rPr sz="1700" b="0">
                 <a:solidFill>
                   <a:srgbClr val="D6DEE8"/>
                 </a:solidFill>
               </a:rPr>
-              <a:t>test_keypad_layer.py — 30 verificações que executam o binário em C de verdade, digitam teclas em stdin e conferem os eventos</a:t>
-            </a:r>
-          </a:p>
-          <a:p>
-            <a:pPr algn="l">
-              <a:spcAft>
-                <a:spcPts val="400"/>
-              </a:spcAft>
-            </a:pPr>
-            <a:r>
-              <a:rPr sz="1300" b="0">
-                <a:solidFill>
-                  <a:srgbClr val="D6DEE8"/>
-                </a:solidFill>
-              </a:rPr>
-              <a:t>test_lichess.py e test_challenge.py — modo online contra um servidor falso da Board API</a:t>
-            </a:r>
-          </a:p>
-          <a:p>
-            <a:pPr algn="l">
-              <a:spcAft>
-                <a:spcPts val="400"/>
-              </a:spcAft>
-            </a:pPr>
-            <a:r>
-              <a:rPr sz="1300" b="0">
-                <a:solidFill>
-                  <a:srgbClr val="D6DEE8"/>
-                </a:solidFill>
-              </a:rPr>
-              <a:t>test_stockfish_loop.py — regressão do loop principal com engine falsa</a:t>
-            </a:r>
-          </a:p>
-          <a:p>
-            <a:pPr algn="l">
-              <a:spcAft>
-                <a:spcPts val="400"/>
-              </a:spcAft>
-            </a:pPr>
-            <a:r>
-              <a:rPr sz="1300" b="0">
-                <a:solidFill>
-                  <a:srgbClr val="D6DEE8"/>
-                </a:solidFill>
-              </a:rPr>
-              <a:t>Resultado: todas as 4 suítes passaram</a:t>
-            </a:r>
-          </a:p>
-        </p:txBody>
-      </p:sp>
-      <p:sp>
-        <p:nvSpPr>
-          <p:cNvPr id="6" name="Rounded Rectangle 5"/>
-          <p:cNvSpPr/>
-          <p:nvPr/>
-        </p:nvSpPr>
-        <p:spPr>
-          <a:xfrm>
-            <a:off x="6492240" y="1783080"/>
-            <a:ext cx="5349240" cy="2514600"/>
-          </a:xfrm>
-          <a:prstGeom prst="roundRect">
-            <a:avLst>
-              <a:gd name="adj" fmla="val 6000"/>
-            </a:avLst>
-          </a:prstGeom>
-          <a:solidFill>
-            <a:srgbClr val="172740"/>
-          </a:solidFill>
-          <a:ln w="15875">
-            <a:solidFill>
-              <a:srgbClr val="E2B714"/>
-            </a:solidFill>
-          </a:ln>
-          <a:effectLst/>
-        </p:spPr>
-        <p:style>
-          <a:lnRef idx="1">
-            <a:schemeClr val="accent1"/>
-          </a:lnRef>
-          <a:fillRef idx="3">
-            <a:schemeClr val="accent1"/>
-          </a:fillRef>
-          <a:effectRef idx="2">
-            <a:schemeClr val="accent1"/>
-          </a:effectRef>
-          <a:fontRef idx="minor">
-            <a:schemeClr val="lt1"/>
-          </a:fontRef>
-        </p:style>
-        <p:txBody>
-          <a:bodyPr rtlCol="0" anchor="t" wrap="square" lIns="201168" rIns="201168" tIns="164592" bIns="164592"/>
-          <a:lstStyle/>
-          <a:p>
-            <a:pPr algn="l">
-              <a:spcAft>
-                <a:spcPts val="600"/>
-              </a:spcAft>
-            </a:pPr>
-            <a:r>
-              <a:rPr sz="1700" b="1">
-                <a:solidFill>
-                  <a:srgbClr val="E2B714"/>
-                </a:solidFill>
-              </a:rPr>
-              <a:t>O que as evidências mostram</a:t>
-            </a:r>
-          </a:p>
-          <a:p>
-            <a:pPr algn="l">
-              <a:spcAft>
-                <a:spcPts val="400"/>
-              </a:spcAft>
-            </a:pPr>
-            <a:r>
-              <a:rPr sz="1300" b="0">
-                <a:solidFill>
-                  <a:srgbClr val="D6DEE8"/>
-                </a:solidFill>
-              </a:rPr>
-              <a:t>O roque funciona pelo teclado: cinco lances produzem os mesmos eventos que o tabuleiro físico produziria</a:t>
-            </a:r>
-          </a:p>
-          <a:p>
-            <a:pPr algn="l">
-              <a:spcAft>
-                <a:spcPts val="400"/>
-              </a:spcAft>
-            </a:pPr>
-            <a:r>
-              <a:rPr sz="1300" b="0">
-                <a:solidFill>
-                  <a:srgbClr val="D6DEE8"/>
-                </a:solidFill>
-              </a:rPr>
-              <a:t>A troca de camada é transparente: AA2AA4# gera e2:0,e4:1, idêntico ao que a matriz de reed switches emitiria</a:t>
-            </a:r>
-          </a:p>
-          <a:p>
-            <a:pPr algn="l">
-              <a:spcAft>
-                <a:spcPts val="400"/>
-              </a:spcAft>
-            </a:pPr>
-            <a:r>
-              <a:rPr sz="1300" b="0">
-                <a:solidFill>
-                  <a:srgbClr val="D6DEE8"/>
-                </a:solidFill>
-              </a:rPr>
-              <a:t>As linhas @entry não contaminam o canal de eventos — a extensão do protocolo é retrocompatível</a:t>
-            </a:r>
-          </a:p>
-          <a:p>
-            <a:pPr algn="l">
-              <a:spcAft>
-                <a:spcPts val="400"/>
-              </a:spcAft>
-            </a:pPr>
-            <a:r>
-              <a:rPr sz="1300" b="0">
-                <a:solidFill>
-                  <a:srgbClr val="D6DEE8"/>
-                </a:solidFill>
-              </a:rPr>
-              <a:t>Recusas locais corretas: origem vazia, destino ocupado, origem igual ao destino</a:t>
-            </a:r>
-          </a:p>
-        </p:txBody>
-      </p:sp>
-      <p:sp>
-        <p:nvSpPr>
-          <p:cNvPr id="7" name="Rounded Rectangle 6"/>
-          <p:cNvSpPr/>
-          <p:nvPr/>
-        </p:nvSpPr>
-        <p:spPr>
-          <a:xfrm>
-            <a:off x="685800" y="4572000"/>
-            <a:ext cx="10820095" cy="1554480"/>
-          </a:xfrm>
-          <a:prstGeom prst="roundRect">
-            <a:avLst>
-              <a:gd name="adj" fmla="val 6000"/>
-            </a:avLst>
-          </a:prstGeom>
-          <a:solidFill>
-            <a:srgbClr val="172740"/>
-          </a:solidFill>
-          <a:ln w="15875">
-            <a:solidFill>
-              <a:srgbClr val="E2B714"/>
-            </a:solidFill>
-          </a:ln>
-          <a:effectLst/>
-        </p:spPr>
-        <p:style>
-          <a:lnRef idx="1">
-            <a:schemeClr val="accent1"/>
-          </a:lnRef>
-          <a:fillRef idx="3">
-            <a:schemeClr val="accent1"/>
-          </a:fillRef>
-          <a:effectRef idx="2">
-            <a:schemeClr val="accent1"/>
-          </a:effectRef>
-          <a:fontRef idx="minor">
-            <a:schemeClr val="lt1"/>
-          </a:fontRef>
-        </p:style>
-        <p:txBody>
-          <a:bodyPr rtlCol="0" anchor="t" wrap="square" lIns="201168" rIns="201168" tIns="164592" bIns="164592"/>
-          <a:lstStyle/>
-          <a:p>
-            <a:pPr algn="l">
-              <a:spcAft>
-                <a:spcPts val="600"/>
-              </a:spcAft>
-            </a:pPr>
-            <a:r>
-              <a:rPr sz="1700" b="1">
-                <a:solidFill>
-                  <a:srgbClr val="E2B714"/>
-                </a:solidFill>
-              </a:rPr>
-              <a:t>Validação de hardware</a:t>
-            </a:r>
-          </a:p>
-          <a:p>
-            <a:pPr algn="l">
-              <a:spcAft>
-                <a:spcPts val="400"/>
-              </a:spcAft>
-            </a:pPr>
-            <a:r>
-              <a:rPr sz="1300" b="0">
-                <a:solidFill>
-                  <a:srgbClr val="D6DEE8"/>
-                </a:solidFill>
-              </a:rPr>
-              <a:t>Teclado matricial testado com hardware real (linhas BCM 16/20/21/26, colunas 19/13/6/5), conferido com o modo de bancada --raw, que mostra em que interseção da matriz cada tecla foi lida.</a:t>
-            </a:r>
-          </a:p>
-          <a:p>
-            <a:pPr algn="l">
-              <a:spcAft>
-                <a:spcPts val="400"/>
-              </a:spcAft>
-            </a:pPr>
-            <a:r>
-              <a:rPr sz="1300" b="0">
-                <a:solidFill>
-                  <a:srgbClr val="D6DEE8"/>
-                </a:solidFill>
-              </a:rPr>
-              <a:t>Tabuleiro instrumentado: cerca de duas fileiras completas montadas com reed switches e diodos — suficiente para confirmar em escala real o mapeamento de linhas e colunas e a detecção através da chapa.</a:t>
+              <a:t>Partida contra o Stockfish pelo teclado matricial  ·  partida online via Lichess  ·  mock gráfico dos reed switches  ·  fileiras montadas do tabuleiro</a:t>
             </a:r>
           </a:p>
         </p:txBody>
@@ -7330,7 +7311,7 @@
                   <a:srgbClr val="F2F4F8"/>
                 </a:solidFill>
               </a:rPr>
-              <a:t>Resultados por requisito</a:t>
+              <a:t>Testes realizados</a:t>
             </a:r>
           </a:p>
           <a:p>
@@ -7345,7 +7326,7 @@
                   <a:srgbClr val="9FB3C8"/>
                 </a:solidFill>
               </a:rPr>
-              <a:t>Rastreabilidade requisito × evidência</a:t>
+              <a:t>Cinco suítes automatizadas, sem depender de token, rede, Stockfish ou display</a:t>
             </a:r>
           </a:p>
         </p:txBody>
@@ -7403,7 +7384,7 @@
         <p:spPr>
           <a:xfrm>
             <a:off x="685800" y="1783080"/>
-            <a:ext cx="10820095" cy="566928"/>
+            <a:ext cx="5349240" cy="2880360"/>
           </a:xfrm>
           <a:prstGeom prst="roundRect">
             <a:avLst>
@@ -7415,7 +7396,7 @@
           </a:solidFill>
           <a:ln w="15875">
             <a:solidFill>
-              <a:srgbClr val="2A4063"/>
+              <a:srgbClr val="4CC38A"/>
             </a:solidFill>
           </a:ln>
           <a:effectLst/>
@@ -7435,37 +7416,96 @@
           </a:fontRef>
         </p:style>
         <p:txBody>
-          <a:bodyPr rtlCol="0" anchor="ctr" wrap="square" lIns="201168"/>
-          <a:lstStyle/>
-          <a:p>
-            <a:pPr algn="ctr">
-              <a:spcAft>
-                <a:spcPts val="0"/>
-              </a:spcAft>
-            </a:pPr>
-            <a:r>
-              <a:rPr sz="1500" b="1">
-                <a:solidFill>
-                  <a:srgbClr val="E2B714"/>
-                </a:solidFill>
-              </a:rPr>
-              <a:t>RF1   </a:t>
-            </a:r>
-            <a:r>
-              <a:rPr sz="1400" b="0">
-                <a:solidFill>
-                  <a:srgbClr val="F2F4F8"/>
-                </a:solidFill>
-              </a:rPr>
-              <a:t>Detecção das peças e movimentos      </a:t>
-            </a:r>
+          <a:bodyPr rtlCol="0" anchor="t" wrap="square" lIns="201168" rIns="201168" tIns="164592" bIns="164592"/>
+          <a:lstStyle/>
+          <a:p>
+            <a:pPr algn="l">
+              <a:spcAft>
+                <a:spcPts val="600"/>
+              </a:spcAft>
+            </a:pPr>
+            <a:r>
+              <a:rPr sz="1700" b="1">
+                <a:solidFill>
+                  <a:srgbClr val="4CC38A"/>
+                </a:solidFill>
+              </a:rPr>
+              <a:t>Suítes  (make test)</a:t>
+            </a:r>
+          </a:p>
+          <a:p>
+            <a:pPr algn="l">
+              <a:spcAft>
+                <a:spcPts val="400"/>
+              </a:spcAft>
+            </a:pPr>
             <a:r>
               <a:rPr sz="1300" b="0">
                 <a:solidFill>
                   <a:srgbClr val="D6DEE8"/>
                 </a:solidFill>
               </a:rPr>
-              <a:t>Software validado (mock + loop principal); hardware parcial — 2 fileiras montadas</a:t>
+              <a:t>test_keypad_layer.py — 30 verificações que executam o binário em C de verdade, digitam teclas em stdin e conferem os eventos</a:t>
+            </a:r>
+          </a:p>
+          <a:p>
+            <a:pPr algn="l">
+              <a:spcAft>
+                <a:spcPts val="400"/>
+              </a:spcAft>
+            </a:pPr>
+            <a:r>
+              <a:rPr sz="1300" b="0">
+                <a:solidFill>
+                  <a:srgbClr val="D6DEE8"/>
+                </a:solidFill>
+              </a:rPr>
+              <a:t>test_keypad_capture.py — retirada automática da peça capturada: canal @sync, validação de payload, integração com a aplicação</a:t>
+            </a:r>
+          </a:p>
+          <a:p>
+            <a:pPr algn="l">
+              <a:spcAft>
+                <a:spcPts val="400"/>
+              </a:spcAft>
+            </a:pPr>
+            <a:r>
+              <a:rPr sz="1300" b="0">
+                <a:solidFill>
+                  <a:srgbClr val="D6DEE8"/>
+                </a:solidFill>
+              </a:rPr>
+              <a:t>test_lichess.py e test_challenge.py — modo online contra um servidor falso da Board API</a:t>
+            </a:r>
+          </a:p>
+          <a:p>
+            <a:pPr algn="l">
+              <a:spcAft>
+                <a:spcPts val="400"/>
+              </a:spcAft>
+            </a:pPr>
+            <a:r>
+              <a:rPr sz="1300" b="0">
+                <a:solidFill>
+                  <a:srgbClr val="D6DEE8"/>
+                </a:solidFill>
+              </a:rPr>
+              <a:t>test_stockfish_loop.py — regressão do loop principal com engine falsa</a:t>
+            </a:r>
+          </a:p>
+          <a:p>
+            <a:pPr algn="l">
+              <a:spcAft>
+                <a:spcPts val="400"/>
+              </a:spcAft>
+            </a:pPr>
+            <a:r>
+              <a:rPr sz="1300" b="0">
+                <a:solidFill>
+                  <a:srgbClr val="D6DEE8"/>
+                </a:solidFill>
+              </a:rPr>
+              <a:t>Resultado: todas as 5 suítes passaram</a:t>
             </a:r>
           </a:p>
         </p:txBody>
@@ -7478,8 +7518,8 @@
         </p:nvSpPr>
         <p:spPr>
           <a:xfrm>
-            <a:off x="685800" y="2441448"/>
-            <a:ext cx="10820095" cy="566928"/>
+            <a:off x="6492240" y="1783080"/>
+            <a:ext cx="5349240" cy="2880360"/>
           </a:xfrm>
           <a:prstGeom prst="roundRect">
             <a:avLst>
@@ -7491,7 +7531,7 @@
           </a:solidFill>
           <a:ln w="15875">
             <a:solidFill>
-              <a:srgbClr val="2A4063"/>
+              <a:srgbClr val="E2B714"/>
             </a:solidFill>
           </a:ln>
           <a:effectLst/>
@@ -7511,37 +7551,96 @@
           </a:fontRef>
         </p:style>
         <p:txBody>
-          <a:bodyPr rtlCol="0" anchor="ctr" wrap="square" lIns="201168"/>
-          <a:lstStyle/>
-          <a:p>
-            <a:pPr algn="ctr">
-              <a:spcAft>
-                <a:spcPts val="0"/>
-              </a:spcAft>
-            </a:pPr>
-            <a:r>
-              <a:rPr sz="1500" b="1">
-                <a:solidFill>
-                  <a:srgbClr val="4CC38A"/>
-                </a:solidFill>
-              </a:rPr>
-              <a:t>RF2   </a:t>
-            </a:r>
-            <a:r>
-              <a:rPr sz="1400" b="0">
-                <a:solidFill>
-                  <a:srgbClr val="F2F4F8"/>
-                </a:solidFill>
-              </a:rPr>
-              <a:t>Comunicação com a chess engine      </a:t>
-            </a:r>
+          <a:bodyPr rtlCol="0" anchor="t" wrap="square" lIns="201168" rIns="201168" tIns="164592" bIns="164592"/>
+          <a:lstStyle/>
+          <a:p>
+            <a:pPr algn="l">
+              <a:spcAft>
+                <a:spcPts val="600"/>
+              </a:spcAft>
+            </a:pPr>
+            <a:r>
+              <a:rPr sz="1700" b="1">
+                <a:solidFill>
+                  <a:srgbClr val="E2B714"/>
+                </a:solidFill>
+              </a:rPr>
+              <a:t>O que as evidências mostram</a:t>
+            </a:r>
+          </a:p>
+          <a:p>
+            <a:pPr algn="l">
+              <a:spcAft>
+                <a:spcPts val="400"/>
+              </a:spcAft>
+            </a:pPr>
             <a:r>
               <a:rPr sz="1300" b="0">
                 <a:solidFill>
                   <a:srgbClr val="D6DEE8"/>
                 </a:solidFill>
               </a:rPr>
-              <a:t>Atendido — Stockfish via UCI e Lichess Board API, cobertos por testes</a:t>
+              <a:t>O roque funciona pelo teclado: cinco lances produzem os mesmos eventos que o tabuleiro físico produziria</a:t>
+            </a:r>
+          </a:p>
+          <a:p>
+            <a:pPr algn="l">
+              <a:spcAft>
+                <a:spcPts val="400"/>
+              </a:spcAft>
+            </a:pPr>
+            <a:r>
+              <a:rPr sz="1300" b="0">
+                <a:solidFill>
+                  <a:srgbClr val="D6DEE8"/>
+                </a:solidFill>
+              </a:rPr>
+              <a:t>A troca de camada é transparente: AA2AA4# gera e2:0,e4:1, idêntico ao que a matriz de reed switches emitiria</a:t>
+            </a:r>
+          </a:p>
+          <a:p>
+            <a:pPr algn="l">
+              <a:spcAft>
+                <a:spcPts val="400"/>
+              </a:spcAft>
+            </a:pPr>
+            <a:r>
+              <a:rPr sz="1300" b="0">
+                <a:solidFill>
+                  <a:srgbClr val="D6DEE8"/>
+                </a:solidFill>
+              </a:rPr>
+              <a:t>Peça capturada pelo oponente sai do espelho sozinha, sem intervenção manual — e o LCD mostra qual peça tirar da mesa</a:t>
+            </a:r>
+          </a:p>
+          <a:p>
+            <a:pPr algn="l">
+              <a:spcAft>
+                <a:spcPts val="400"/>
+              </a:spcAft>
+            </a:pPr>
+            <a:r>
+              <a:rPr sz="1300" b="0">
+                <a:solidFill>
+                  <a:srgbClr val="D6DEE8"/>
+                </a:solidFill>
+              </a:rPr>
+              <a:t>Canal @sync não gera evento de volta — a extensão é retrocompatível</a:t>
+            </a:r>
+          </a:p>
+          <a:p>
+            <a:pPr algn="l">
+              <a:spcAft>
+                <a:spcPts val="400"/>
+              </a:spcAft>
+            </a:pPr>
+            <a:r>
+              <a:rPr sz="1300" b="0">
+                <a:solidFill>
+                  <a:srgbClr val="D6DEE8"/>
+                </a:solidFill>
+              </a:rPr>
+              <a:t>Payloads malformados (curto, inválido, desconhecido) são ignorados: meio espelho aplicado nunca acontece</a:t>
             </a:r>
           </a:p>
         </p:txBody>
@@ -7554,8 +7653,8 @@
         </p:nvSpPr>
         <p:spPr>
           <a:xfrm>
-            <a:off x="685800" y="3099816"/>
-            <a:ext cx="10820095" cy="566928"/>
+            <a:off x="685800" y="4892040"/>
+            <a:ext cx="10820095" cy="1371600"/>
           </a:xfrm>
           <a:prstGeom prst="roundRect">
             <a:avLst>
@@ -7567,7 +7666,7 @@
           </a:solidFill>
           <a:ln w="15875">
             <a:solidFill>
-              <a:srgbClr val="2A4063"/>
+              <a:srgbClr val="E2B714"/>
             </a:solidFill>
           </a:ln>
           <a:effectLst/>
@@ -7587,303 +7686,51 @@
           </a:fontRef>
         </p:style>
         <p:txBody>
-          <a:bodyPr rtlCol="0" anchor="ctr" wrap="square" lIns="201168"/>
-          <a:lstStyle/>
-          <a:p>
-            <a:pPr algn="ctr">
-              <a:spcAft>
-                <a:spcPts val="0"/>
-              </a:spcAft>
-            </a:pPr>
-            <a:r>
-              <a:rPr sz="1500" b="1">
-                <a:solidFill>
-                  <a:srgbClr val="4CC38A"/>
-                </a:solidFill>
-              </a:rPr>
-              <a:t>RF3   </a:t>
-            </a:r>
-            <a:r>
-              <a:rPr sz="1400" b="0">
-                <a:solidFill>
-                  <a:srgbClr val="F2F4F8"/>
-                </a:solidFill>
-              </a:rPr>
-              <a:t>Exibição gráfica das duas partes      </a:t>
-            </a:r>
+          <a:bodyPr rtlCol="0" anchor="t" wrap="square" lIns="201168" rIns="201168" tIns="164592" bIns="164592"/>
+          <a:lstStyle/>
+          <a:p>
+            <a:pPr algn="l">
+              <a:spcAft>
+                <a:spcPts val="600"/>
+              </a:spcAft>
+            </a:pPr>
+            <a:r>
+              <a:rPr sz="1700" b="1">
+                <a:solidFill>
+                  <a:srgbClr val="E2B714"/>
+                </a:solidFill>
+              </a:rPr>
+              <a:t>Validação de hardware</a:t>
+            </a:r>
+          </a:p>
+          <a:p>
+            <a:pPr algn="l">
+              <a:spcAft>
+                <a:spcPts val="400"/>
+              </a:spcAft>
+            </a:pPr>
             <a:r>
               <a:rPr sz="1300" b="0">
                 <a:solidFill>
                   <a:srgbClr val="D6DEE8"/>
                 </a:solidFill>
               </a:rPr>
-              <a:t>Atendido — GUI pygame com 32 peças, destaques e barra de instruções</a:t>
-            </a:r>
-          </a:p>
-        </p:txBody>
-      </p:sp>
-      <p:sp>
-        <p:nvSpPr>
-          <p:cNvPr id="8" name="Rounded Rectangle 7"/>
-          <p:cNvSpPr/>
-          <p:nvPr/>
-        </p:nvSpPr>
-        <p:spPr>
-          <a:xfrm>
-            <a:off x="685800" y="3758184"/>
-            <a:ext cx="10820095" cy="566928"/>
-          </a:xfrm>
-          <a:prstGeom prst="roundRect">
-            <a:avLst>
-              <a:gd name="adj" fmla="val 6000"/>
-            </a:avLst>
-          </a:prstGeom>
-          <a:solidFill>
-            <a:srgbClr val="172740"/>
-          </a:solidFill>
-          <a:ln w="15875">
-            <a:solidFill>
-              <a:srgbClr val="2A4063"/>
-            </a:solidFill>
-          </a:ln>
-          <a:effectLst/>
-        </p:spPr>
-        <p:style>
-          <a:lnRef idx="1">
-            <a:schemeClr val="accent1"/>
-          </a:lnRef>
-          <a:fillRef idx="3">
-            <a:schemeClr val="accent1"/>
-          </a:fillRef>
-          <a:effectRef idx="2">
-            <a:schemeClr val="accent1"/>
-          </a:effectRef>
-          <a:fontRef idx="minor">
-            <a:schemeClr val="lt1"/>
-          </a:fontRef>
-        </p:style>
-        <p:txBody>
-          <a:bodyPr rtlCol="0" anchor="ctr" wrap="square" lIns="201168"/>
-          <a:lstStyle/>
-          <a:p>
-            <a:pPr algn="ctr">
-              <a:spcAft>
-                <a:spcPts val="0"/>
-              </a:spcAft>
-            </a:pPr>
-            <a:r>
-              <a:rPr sz="1500" b="1">
-                <a:solidFill>
-                  <a:srgbClr val="E2B714"/>
-                </a:solidFill>
-              </a:rPr>
-              <a:t>RNF1   </a:t>
-            </a:r>
-            <a:r>
-              <a:rPr sz="1400" b="0">
-                <a:solidFill>
-                  <a:srgbClr val="F2F4F8"/>
-                </a:solidFill>
-              </a:rPr>
-              <a:t>Detecção &lt; 200 ms e 100 % de precisão      </a:t>
-            </a:r>
+              <a:t>Teclado matricial testado com hardware real (linhas BCM 16/20/21/26, colunas 19/13/6/5), conferido com o modo de bancada --raw, que mostra em que interseção da matriz cada tecla foi lida.</a:t>
+            </a:r>
+          </a:p>
+          <a:p>
+            <a:pPr algn="l">
+              <a:spcAft>
+                <a:spcPts val="400"/>
+              </a:spcAft>
+            </a:pPr>
             <a:r>
               <a:rPr sz="1300" b="0">
                 <a:solidFill>
                   <a:srgbClr val="D6DEE8"/>
                 </a:solidFill>
               </a:rPr>
-              <a:t>Precisão 30/30 nos eventos verificados; medição de latência pendente</a:t>
-            </a:r>
-          </a:p>
-        </p:txBody>
-      </p:sp>
-      <p:sp>
-        <p:nvSpPr>
-          <p:cNvPr id="9" name="Rounded Rectangle 8"/>
-          <p:cNvSpPr/>
-          <p:nvPr/>
-        </p:nvSpPr>
-        <p:spPr>
-          <a:xfrm>
-            <a:off x="685800" y="4416552"/>
-            <a:ext cx="10820095" cy="566928"/>
-          </a:xfrm>
-          <a:prstGeom prst="roundRect">
-            <a:avLst>
-              <a:gd name="adj" fmla="val 6000"/>
-            </a:avLst>
-          </a:prstGeom>
-          <a:solidFill>
-            <a:srgbClr val="172740"/>
-          </a:solidFill>
-          <a:ln w="15875">
-            <a:solidFill>
-              <a:srgbClr val="2A4063"/>
-            </a:solidFill>
-          </a:ln>
-          <a:effectLst/>
-        </p:spPr>
-        <p:style>
-          <a:lnRef idx="1">
-            <a:schemeClr val="accent1"/>
-          </a:lnRef>
-          <a:fillRef idx="3">
-            <a:schemeClr val="accent1"/>
-          </a:fillRef>
-          <a:effectRef idx="2">
-            <a:schemeClr val="accent1"/>
-          </a:effectRef>
-          <a:fontRef idx="minor">
-            <a:schemeClr val="lt1"/>
-          </a:fontRef>
-        </p:style>
-        <p:txBody>
-          <a:bodyPr rtlCol="0" anchor="ctr" wrap="square" lIns="201168"/>
-          <a:lstStyle/>
-          <a:p>
-            <a:pPr algn="ctr">
-              <a:spcAft>
-                <a:spcPts val="0"/>
-              </a:spcAft>
-            </a:pPr>
-            <a:r>
-              <a:rPr sz="1500" b="1">
-                <a:solidFill>
-                  <a:srgbClr val="E2B714"/>
-                </a:solidFill>
-              </a:rPr>
-              <a:t>RNF2   </a:t>
-            </a:r>
-            <a:r>
-              <a:rPr sz="1400" b="0">
-                <a:solidFill>
-                  <a:srgbClr val="F2F4F8"/>
-                </a:solidFill>
-              </a:rPr>
-              <a:t>GUI sem latência considerável      </a:t>
-            </a:r>
-            <a:r>
-              <a:rPr sz="1300" b="0">
-                <a:solidFill>
-                  <a:srgbClr val="D6DEE8"/>
-                </a:solidFill>
-              </a:rPr>
-              <a:t>Renderização incremental implementada; instrumentação de tempos pendente</a:t>
-            </a:r>
-          </a:p>
-        </p:txBody>
-      </p:sp>
-      <p:sp>
-        <p:nvSpPr>
-          <p:cNvPr id="10" name="Rounded Rectangle 9"/>
-          <p:cNvSpPr/>
-          <p:nvPr/>
-        </p:nvSpPr>
-        <p:spPr>
-          <a:xfrm>
-            <a:off x="685800" y="5074920"/>
-            <a:ext cx="10820095" cy="566928"/>
-          </a:xfrm>
-          <a:prstGeom prst="roundRect">
-            <a:avLst>
-              <a:gd name="adj" fmla="val 6000"/>
-            </a:avLst>
-          </a:prstGeom>
-          <a:solidFill>
-            <a:srgbClr val="172740"/>
-          </a:solidFill>
-          <a:ln w="15875">
-            <a:solidFill>
-              <a:srgbClr val="2A4063"/>
-            </a:solidFill>
-          </a:ln>
-          <a:effectLst/>
-        </p:spPr>
-        <p:style>
-          <a:lnRef idx="1">
-            <a:schemeClr val="accent1"/>
-          </a:lnRef>
-          <a:fillRef idx="3">
-            <a:schemeClr val="accent1"/>
-          </a:fillRef>
-          <a:effectRef idx="2">
-            <a:schemeClr val="accent1"/>
-          </a:effectRef>
-          <a:fontRef idx="minor">
-            <a:schemeClr val="lt1"/>
-          </a:fontRef>
-        </p:style>
-        <p:txBody>
-          <a:bodyPr rtlCol="0" anchor="ctr" wrap="square" lIns="201168"/>
-          <a:lstStyle/>
-          <a:p>
-            <a:pPr algn="ctr">
-              <a:spcAft>
-                <a:spcPts val="0"/>
-              </a:spcAft>
-            </a:pPr>
-            <a:r>
-              <a:rPr sz="1500" b="1">
-                <a:solidFill>
-                  <a:srgbClr val="E2B714"/>
-                </a:solidFill>
-              </a:rPr>
-              <a:t>RNF3   </a:t>
-            </a:r>
-            <a:r>
-              <a:rPr sz="1400" b="0">
-                <a:solidFill>
-                  <a:srgbClr val="F2F4F8"/>
-                </a:solidFill>
-              </a:rPr>
-              <a:t>Robustez contra falsos positivos      </a:t>
-            </a:r>
-            <a:r>
-              <a:rPr sz="1300" b="0">
-                <a:solidFill>
-                  <a:srgbClr val="D6DEE8"/>
-                </a:solidFill>
-              </a:rPr>
-              <a:t>Dupla barreira (debouncing em C + validação em Python) e ressincronização; debouncing em hardware pendente</a:t>
-            </a:r>
-          </a:p>
-        </p:txBody>
-      </p:sp>
-      <p:sp>
-        <p:nvSpPr>
-          <p:cNvPr id="11" name="TextBox 10"/>
-          <p:cNvSpPr txBox="1"/>
-          <p:nvPr/>
-        </p:nvSpPr>
-        <p:spPr>
-          <a:xfrm>
-            <a:off x="685800" y="6291072"/>
-            <a:ext cx="10820095" cy="320040"/>
-          </a:xfrm>
-          <a:prstGeom prst="rect">
-            <a:avLst/>
-          </a:prstGeom>
-          <a:noFill/>
-        </p:spPr>
-        <p:txBody>
-          <a:bodyPr wrap="square" lIns="0" rIns="0" tIns="0" bIns="0">
-            <a:spAutoFit/>
-          </a:bodyPr>
-          <a:lstStyle/>
-          <a:p>
-            <a:pPr algn="l">
-              <a:spcAft>
-                <a:spcPts val="0"/>
-              </a:spcAft>
-            </a:pPr>
-            <a:r>
-              <a:rPr sz="1100" b="0">
-                <a:solidFill>
-                  <a:srgbClr val="9FB3C8"/>
-                </a:solidFill>
-              </a:rPr>
-              <a:t>As pendências são de medição, não de implementação: exigem instrumentar o caminho completo no Raspberry Pi.</a:t>
+              <a:t>Tabuleiro instrumentado: cerca de duas fileiras completas montadas com reed switches e diodos — suficiente para confirmar em escala real o mapeamento de linhas e colunas e a detecção através da chapa.</a:t>
             </a:r>
           </a:p>
         </p:txBody>
@@ -7983,7 +7830,7 @@
                   <a:srgbClr val="F2F4F8"/>
                 </a:solidFill>
               </a:rPr>
-              <a:t>Dificuldades encontradas</a:t>
+              <a:t>Resultados por requisito</a:t>
             </a:r>
           </a:p>
           <a:p>
@@ -7998,7 +7845,7 @@
                   <a:srgbClr val="9FB3C8"/>
                 </a:solidFill>
               </a:rPr>
-              <a:t>O que custou tempo e o que aprendemos</a:t>
+              <a:t>Rastreabilidade requisito × evidência</a:t>
             </a:r>
           </a:p>
         </p:txBody>
@@ -8049,58 +7896,470 @@
       </p:sp>
       <p:sp>
         <p:nvSpPr>
-          <p:cNvPr id="5" name="Rectangle 4"/>
-          <p:cNvSpPr/>
-          <p:nvPr/>
-        </p:nvSpPr>
-        <p:spPr>
-          <a:xfrm>
-            <a:off x="685800" y="1792224"/>
-            <a:ext cx="44450" cy="658368"/>
-          </a:xfrm>
-          <a:prstGeom prst="rect">
-            <a:avLst/>
-          </a:prstGeom>
-          <a:solidFill>
-            <a:srgbClr val="E2B714"/>
-          </a:solidFill>
-          <a:ln>
-            <a:noFill/>
-          </a:ln>
-          <a:effectLst/>
-        </p:spPr>
-        <p:style>
-          <a:lnRef idx="1">
-            <a:schemeClr val="accent1"/>
-          </a:lnRef>
-          <a:fillRef idx="3">
-            <a:schemeClr val="accent1"/>
-          </a:fillRef>
-          <a:effectRef idx="2">
-            <a:schemeClr val="accent1"/>
-          </a:effectRef>
-          <a:fontRef idx="minor">
-            <a:schemeClr val="lt1"/>
-          </a:fontRef>
-        </p:style>
-        <p:txBody>
-          <a:bodyPr rtlCol="0" anchor="ctr"/>
-          <a:lstStyle/>
-          <a:p>
-            <a:pPr algn="ctr"/>
-          </a:p>
-        </p:txBody>
-      </p:sp>
-      <p:sp>
-        <p:nvSpPr>
-          <p:cNvPr id="6" name="TextBox 5"/>
+          <p:cNvPr id="5" name="Rounded Rectangle 4"/>
+          <p:cNvSpPr/>
+          <p:nvPr/>
+        </p:nvSpPr>
+        <p:spPr>
+          <a:xfrm>
+            <a:off x="685800" y="1783080"/>
+            <a:ext cx="10820095" cy="566928"/>
+          </a:xfrm>
+          <a:prstGeom prst="roundRect">
+            <a:avLst>
+              <a:gd name="adj" fmla="val 6000"/>
+            </a:avLst>
+          </a:prstGeom>
+          <a:solidFill>
+            <a:srgbClr val="172740"/>
+          </a:solidFill>
+          <a:ln w="15875">
+            <a:solidFill>
+              <a:srgbClr val="2A4063"/>
+            </a:solidFill>
+          </a:ln>
+          <a:effectLst/>
+        </p:spPr>
+        <p:style>
+          <a:lnRef idx="1">
+            <a:schemeClr val="accent1"/>
+          </a:lnRef>
+          <a:fillRef idx="3">
+            <a:schemeClr val="accent1"/>
+          </a:fillRef>
+          <a:effectRef idx="2">
+            <a:schemeClr val="accent1"/>
+          </a:effectRef>
+          <a:fontRef idx="minor">
+            <a:schemeClr val="lt1"/>
+          </a:fontRef>
+        </p:style>
+        <p:txBody>
+          <a:bodyPr rtlCol="0" anchor="ctr" wrap="square" lIns="201168"/>
+          <a:lstStyle/>
+          <a:p>
+            <a:pPr algn="ctr">
+              <a:spcAft>
+                <a:spcPts val="0"/>
+              </a:spcAft>
+            </a:pPr>
+            <a:r>
+              <a:rPr sz="1500" b="1">
+                <a:solidFill>
+                  <a:srgbClr val="E2B714"/>
+                </a:solidFill>
+              </a:rPr>
+              <a:t>RF1   </a:t>
+            </a:r>
+            <a:r>
+              <a:rPr sz="1400" b="0">
+                <a:solidFill>
+                  <a:srgbClr val="F2F4F8"/>
+                </a:solidFill>
+              </a:rPr>
+              <a:t>Detecção das peças e movimentos      </a:t>
+            </a:r>
+            <a:r>
+              <a:rPr sz="1300" b="0">
+                <a:solidFill>
+                  <a:srgbClr val="D6DEE8"/>
+                </a:solidFill>
+              </a:rPr>
+              <a:t>Software validado (mock + loop principal); hardware parcial — 2 fileiras montadas</a:t>
+            </a:r>
+          </a:p>
+        </p:txBody>
+      </p:sp>
+      <p:sp>
+        <p:nvSpPr>
+          <p:cNvPr id="6" name="Rounded Rectangle 5"/>
+          <p:cNvSpPr/>
+          <p:nvPr/>
+        </p:nvSpPr>
+        <p:spPr>
+          <a:xfrm>
+            <a:off x="685800" y="2441448"/>
+            <a:ext cx="10820095" cy="566928"/>
+          </a:xfrm>
+          <a:prstGeom prst="roundRect">
+            <a:avLst>
+              <a:gd name="adj" fmla="val 6000"/>
+            </a:avLst>
+          </a:prstGeom>
+          <a:solidFill>
+            <a:srgbClr val="172740"/>
+          </a:solidFill>
+          <a:ln w="15875">
+            <a:solidFill>
+              <a:srgbClr val="2A4063"/>
+            </a:solidFill>
+          </a:ln>
+          <a:effectLst/>
+        </p:spPr>
+        <p:style>
+          <a:lnRef idx="1">
+            <a:schemeClr val="accent1"/>
+          </a:lnRef>
+          <a:fillRef idx="3">
+            <a:schemeClr val="accent1"/>
+          </a:fillRef>
+          <a:effectRef idx="2">
+            <a:schemeClr val="accent1"/>
+          </a:effectRef>
+          <a:fontRef idx="minor">
+            <a:schemeClr val="lt1"/>
+          </a:fontRef>
+        </p:style>
+        <p:txBody>
+          <a:bodyPr rtlCol="0" anchor="ctr" wrap="square" lIns="201168"/>
+          <a:lstStyle/>
+          <a:p>
+            <a:pPr algn="ctr">
+              <a:spcAft>
+                <a:spcPts val="0"/>
+              </a:spcAft>
+            </a:pPr>
+            <a:r>
+              <a:rPr sz="1500" b="1">
+                <a:solidFill>
+                  <a:srgbClr val="4CC38A"/>
+                </a:solidFill>
+              </a:rPr>
+              <a:t>RF2   </a:t>
+            </a:r>
+            <a:r>
+              <a:rPr sz="1400" b="0">
+                <a:solidFill>
+                  <a:srgbClr val="F2F4F8"/>
+                </a:solidFill>
+              </a:rPr>
+              <a:t>Comunicação com a chess engine      </a:t>
+            </a:r>
+            <a:r>
+              <a:rPr sz="1300" b="0">
+                <a:solidFill>
+                  <a:srgbClr val="D6DEE8"/>
+                </a:solidFill>
+              </a:rPr>
+              <a:t>Atendido — Stockfish via UCI e Lichess Board API, cobertos por testes</a:t>
+            </a:r>
+          </a:p>
+        </p:txBody>
+      </p:sp>
+      <p:sp>
+        <p:nvSpPr>
+          <p:cNvPr id="7" name="Rounded Rectangle 6"/>
+          <p:cNvSpPr/>
+          <p:nvPr/>
+        </p:nvSpPr>
+        <p:spPr>
+          <a:xfrm>
+            <a:off x="685800" y="3099816"/>
+            <a:ext cx="10820095" cy="566928"/>
+          </a:xfrm>
+          <a:prstGeom prst="roundRect">
+            <a:avLst>
+              <a:gd name="adj" fmla="val 6000"/>
+            </a:avLst>
+          </a:prstGeom>
+          <a:solidFill>
+            <a:srgbClr val="172740"/>
+          </a:solidFill>
+          <a:ln w="15875">
+            <a:solidFill>
+              <a:srgbClr val="2A4063"/>
+            </a:solidFill>
+          </a:ln>
+          <a:effectLst/>
+        </p:spPr>
+        <p:style>
+          <a:lnRef idx="1">
+            <a:schemeClr val="accent1"/>
+          </a:lnRef>
+          <a:fillRef idx="3">
+            <a:schemeClr val="accent1"/>
+          </a:fillRef>
+          <a:effectRef idx="2">
+            <a:schemeClr val="accent1"/>
+          </a:effectRef>
+          <a:fontRef idx="minor">
+            <a:schemeClr val="lt1"/>
+          </a:fontRef>
+        </p:style>
+        <p:txBody>
+          <a:bodyPr rtlCol="0" anchor="ctr" wrap="square" lIns="201168"/>
+          <a:lstStyle/>
+          <a:p>
+            <a:pPr algn="ctr">
+              <a:spcAft>
+                <a:spcPts val="0"/>
+              </a:spcAft>
+            </a:pPr>
+            <a:r>
+              <a:rPr sz="1500" b="1">
+                <a:solidFill>
+                  <a:srgbClr val="4CC38A"/>
+                </a:solidFill>
+              </a:rPr>
+              <a:t>RF3   </a:t>
+            </a:r>
+            <a:r>
+              <a:rPr sz="1400" b="0">
+                <a:solidFill>
+                  <a:srgbClr val="F2F4F8"/>
+                </a:solidFill>
+              </a:rPr>
+              <a:t>Exibição gráfica das duas partes      </a:t>
+            </a:r>
+            <a:r>
+              <a:rPr sz="1300" b="0">
+                <a:solidFill>
+                  <a:srgbClr val="D6DEE8"/>
+                </a:solidFill>
+              </a:rPr>
+              <a:t>Atendido — GUI pygame com 32 peças, destaques e barra de instruções</a:t>
+            </a:r>
+          </a:p>
+        </p:txBody>
+      </p:sp>
+      <p:sp>
+        <p:nvSpPr>
+          <p:cNvPr id="8" name="Rounded Rectangle 7"/>
+          <p:cNvSpPr/>
+          <p:nvPr/>
+        </p:nvSpPr>
+        <p:spPr>
+          <a:xfrm>
+            <a:off x="685800" y="3758184"/>
+            <a:ext cx="10820095" cy="566928"/>
+          </a:xfrm>
+          <a:prstGeom prst="roundRect">
+            <a:avLst>
+              <a:gd name="adj" fmla="val 6000"/>
+            </a:avLst>
+          </a:prstGeom>
+          <a:solidFill>
+            <a:srgbClr val="172740"/>
+          </a:solidFill>
+          <a:ln w="15875">
+            <a:solidFill>
+              <a:srgbClr val="2A4063"/>
+            </a:solidFill>
+          </a:ln>
+          <a:effectLst/>
+        </p:spPr>
+        <p:style>
+          <a:lnRef idx="1">
+            <a:schemeClr val="accent1"/>
+          </a:lnRef>
+          <a:fillRef idx="3">
+            <a:schemeClr val="accent1"/>
+          </a:fillRef>
+          <a:effectRef idx="2">
+            <a:schemeClr val="accent1"/>
+          </a:effectRef>
+          <a:fontRef idx="minor">
+            <a:schemeClr val="lt1"/>
+          </a:fontRef>
+        </p:style>
+        <p:txBody>
+          <a:bodyPr rtlCol="0" anchor="ctr" wrap="square" lIns="201168"/>
+          <a:lstStyle/>
+          <a:p>
+            <a:pPr algn="ctr">
+              <a:spcAft>
+                <a:spcPts val="0"/>
+              </a:spcAft>
+            </a:pPr>
+            <a:r>
+              <a:rPr sz="1500" b="1">
+                <a:solidFill>
+                  <a:srgbClr val="E2B714"/>
+                </a:solidFill>
+              </a:rPr>
+              <a:t>RNF1   </a:t>
+            </a:r>
+            <a:r>
+              <a:rPr sz="1400" b="0">
+                <a:solidFill>
+                  <a:srgbClr val="F2F4F8"/>
+                </a:solidFill>
+              </a:rPr>
+              <a:t>Detecção &lt; 200 ms e 100 % de precisão      </a:t>
+            </a:r>
+            <a:r>
+              <a:rPr sz="1300" b="0">
+                <a:solidFill>
+                  <a:srgbClr val="D6DEE8"/>
+                </a:solidFill>
+              </a:rPr>
+              <a:t>Precisão 30/30 nos eventos verificados; medição de latência pendente</a:t>
+            </a:r>
+          </a:p>
+        </p:txBody>
+      </p:sp>
+      <p:sp>
+        <p:nvSpPr>
+          <p:cNvPr id="9" name="Rounded Rectangle 8"/>
+          <p:cNvSpPr/>
+          <p:nvPr/>
+        </p:nvSpPr>
+        <p:spPr>
+          <a:xfrm>
+            <a:off x="685800" y="4416552"/>
+            <a:ext cx="10820095" cy="566928"/>
+          </a:xfrm>
+          <a:prstGeom prst="roundRect">
+            <a:avLst>
+              <a:gd name="adj" fmla="val 6000"/>
+            </a:avLst>
+          </a:prstGeom>
+          <a:solidFill>
+            <a:srgbClr val="172740"/>
+          </a:solidFill>
+          <a:ln w="15875">
+            <a:solidFill>
+              <a:srgbClr val="2A4063"/>
+            </a:solidFill>
+          </a:ln>
+          <a:effectLst/>
+        </p:spPr>
+        <p:style>
+          <a:lnRef idx="1">
+            <a:schemeClr val="accent1"/>
+          </a:lnRef>
+          <a:fillRef idx="3">
+            <a:schemeClr val="accent1"/>
+          </a:fillRef>
+          <a:effectRef idx="2">
+            <a:schemeClr val="accent1"/>
+          </a:effectRef>
+          <a:fontRef idx="minor">
+            <a:schemeClr val="lt1"/>
+          </a:fontRef>
+        </p:style>
+        <p:txBody>
+          <a:bodyPr rtlCol="0" anchor="ctr" wrap="square" lIns="201168"/>
+          <a:lstStyle/>
+          <a:p>
+            <a:pPr algn="ctr">
+              <a:spcAft>
+                <a:spcPts val="0"/>
+              </a:spcAft>
+            </a:pPr>
+            <a:r>
+              <a:rPr sz="1500" b="1">
+                <a:solidFill>
+                  <a:srgbClr val="E2B714"/>
+                </a:solidFill>
+              </a:rPr>
+              <a:t>RNF2   </a:t>
+            </a:r>
+            <a:r>
+              <a:rPr sz="1400" b="0">
+                <a:solidFill>
+                  <a:srgbClr val="F2F4F8"/>
+                </a:solidFill>
+              </a:rPr>
+              <a:t>GUI sem latência considerável      </a:t>
+            </a:r>
+            <a:r>
+              <a:rPr sz="1300" b="0">
+                <a:solidFill>
+                  <a:srgbClr val="D6DEE8"/>
+                </a:solidFill>
+              </a:rPr>
+              <a:t>Renderização incremental implementada; instrumentação de tempos pendente</a:t>
+            </a:r>
+          </a:p>
+        </p:txBody>
+      </p:sp>
+      <p:sp>
+        <p:nvSpPr>
+          <p:cNvPr id="10" name="Rounded Rectangle 9"/>
+          <p:cNvSpPr/>
+          <p:nvPr/>
+        </p:nvSpPr>
+        <p:spPr>
+          <a:xfrm>
+            <a:off x="685800" y="5074920"/>
+            <a:ext cx="10820095" cy="566928"/>
+          </a:xfrm>
+          <a:prstGeom prst="roundRect">
+            <a:avLst>
+              <a:gd name="adj" fmla="val 6000"/>
+            </a:avLst>
+          </a:prstGeom>
+          <a:solidFill>
+            <a:srgbClr val="172740"/>
+          </a:solidFill>
+          <a:ln w="15875">
+            <a:solidFill>
+              <a:srgbClr val="2A4063"/>
+            </a:solidFill>
+          </a:ln>
+          <a:effectLst/>
+        </p:spPr>
+        <p:style>
+          <a:lnRef idx="1">
+            <a:schemeClr val="accent1"/>
+          </a:lnRef>
+          <a:fillRef idx="3">
+            <a:schemeClr val="accent1"/>
+          </a:fillRef>
+          <a:effectRef idx="2">
+            <a:schemeClr val="accent1"/>
+          </a:effectRef>
+          <a:fontRef idx="minor">
+            <a:schemeClr val="lt1"/>
+          </a:fontRef>
+        </p:style>
+        <p:txBody>
+          <a:bodyPr rtlCol="0" anchor="ctr" wrap="square" lIns="201168"/>
+          <a:lstStyle/>
+          <a:p>
+            <a:pPr algn="ctr">
+              <a:spcAft>
+                <a:spcPts val="0"/>
+              </a:spcAft>
+            </a:pPr>
+            <a:r>
+              <a:rPr sz="1500" b="1">
+                <a:solidFill>
+                  <a:srgbClr val="E2B714"/>
+                </a:solidFill>
+              </a:rPr>
+              <a:t>RNF3   </a:t>
+            </a:r>
+            <a:r>
+              <a:rPr sz="1400" b="0">
+                <a:solidFill>
+                  <a:srgbClr val="F2F4F8"/>
+                </a:solidFill>
+              </a:rPr>
+              <a:t>Robustez contra falsos positivos      </a:t>
+            </a:r>
+            <a:r>
+              <a:rPr sz="1300" b="0">
+                <a:solidFill>
+                  <a:srgbClr val="D6DEE8"/>
+                </a:solidFill>
+              </a:rPr>
+              <a:t>Dupla barreira (debouncing em C + validação em Python), ressincronização e espelho bidirecional (canal @sync); debouncing em hardware pendente</a:t>
+            </a:r>
+          </a:p>
+        </p:txBody>
+      </p:sp>
+      <p:sp>
+        <p:nvSpPr>
+          <p:cNvPr id="11" name="TextBox 10"/>
           <p:cNvSpPr txBox="1"/>
           <p:nvPr/>
         </p:nvSpPr>
         <p:spPr>
           <a:xfrm>
-            <a:off x="941832" y="1737360"/>
-            <a:ext cx="10564063" cy="822960"/>
+            <a:off x="685800" y="6291072"/>
+            <a:ext cx="10820095" cy="320040"/>
           </a:xfrm>
           <a:prstGeom prst="rect">
             <a:avLst/>
@@ -8115,419 +8374,16 @@
           <a:p>
             <a:pPr algn="l">
               <a:spcAft>
-                <a:spcPts val="200"/>
-              </a:spcAft>
-            </a:pPr>
-            <a:r>
-              <a:rPr sz="1700" b="1">
-                <a:solidFill>
-                  <a:srgbClr val="F2F4F8"/>
-                </a:solidFill>
-              </a:rPr>
-              <a:t>Mecânica antes da eletrônica</a:t>
-            </a:r>
-          </a:p>
-          <a:p>
-            <a:pPr algn="l">
-              <a:spcAft>
                 <a:spcPts val="0"/>
               </a:spcAft>
             </a:pPr>
             <a:r>
-              <a:rPr sz="1300" b="0">
-                <a:solidFill>
-                  <a:srgbClr val="D6DEE8"/>
-                </a:solidFill>
-              </a:rPr>
-              <a:t>A chapa de acrílico escolhida ficou espessa demais para o alcance dos ímãs de neodímio. Um detalhe mecânico — não de software nem de circuito — foi o que travou o cronograma do hardware.</a:t>
-            </a:r>
-          </a:p>
-        </p:txBody>
-      </p:sp>
-      <p:sp>
-        <p:nvSpPr>
-          <p:cNvPr id="7" name="Rectangle 6"/>
-          <p:cNvSpPr/>
-          <p:nvPr/>
-        </p:nvSpPr>
-        <p:spPr>
-          <a:xfrm>
-            <a:off x="685800" y="2752344"/>
-            <a:ext cx="44450" cy="658368"/>
-          </a:xfrm>
-          <a:prstGeom prst="rect">
-            <a:avLst/>
-          </a:prstGeom>
-          <a:solidFill>
-            <a:srgbClr val="E2B714"/>
-          </a:solidFill>
-          <a:ln>
-            <a:noFill/>
-          </a:ln>
-          <a:effectLst/>
-        </p:spPr>
-        <p:style>
-          <a:lnRef idx="1">
-            <a:schemeClr val="accent1"/>
-          </a:lnRef>
-          <a:fillRef idx="3">
-            <a:schemeClr val="accent1"/>
-          </a:fillRef>
-          <a:effectRef idx="2">
-            <a:schemeClr val="accent1"/>
-          </a:effectRef>
-          <a:fontRef idx="minor">
-            <a:schemeClr val="lt1"/>
-          </a:fontRef>
-        </p:style>
-        <p:txBody>
-          <a:bodyPr rtlCol="0" anchor="ctr"/>
-          <a:lstStyle/>
-          <a:p>
-            <a:pPr algn="ctr"/>
-          </a:p>
-        </p:txBody>
-      </p:sp>
-      <p:sp>
-        <p:nvSpPr>
-          <p:cNvPr id="8" name="TextBox 7"/>
-          <p:cNvSpPr txBox="1"/>
-          <p:nvPr/>
-        </p:nvSpPr>
-        <p:spPr>
-          <a:xfrm>
-            <a:off x="941832" y="2697480"/>
-            <a:ext cx="10564063" cy="822960"/>
-          </a:xfrm>
-          <a:prstGeom prst="rect">
-            <a:avLst/>
-          </a:prstGeom>
-          <a:noFill/>
-        </p:spPr>
-        <p:txBody>
-          <a:bodyPr wrap="square" lIns="0" rIns="0" tIns="0" bIns="0">
-            <a:spAutoFit/>
-          </a:bodyPr>
-          <a:lstStyle/>
-          <a:p>
-            <a:pPr algn="l">
-              <a:spcAft>
-                <a:spcPts val="200"/>
-              </a:spcAft>
-            </a:pPr>
-            <a:r>
-              <a:rPr sz="1700" b="1">
-                <a:solidFill>
-                  <a:srgbClr val="F2F4F8"/>
-                </a:solidFill>
-              </a:rPr>
-              <a:t>Montagem de 64 casas é trabalho manual</a:t>
-            </a:r>
-          </a:p>
-          <a:p>
-            <a:pPr algn="l">
-              <a:spcAft>
-                <a:spcPts val="0"/>
-              </a:spcAft>
-            </a:pPr>
-            <a:r>
-              <a:rPr sz="1300" b="0">
-                <a:solidFill>
-                  <a:srgbClr val="D6DEE8"/>
-                </a:solidFill>
-              </a:rPr>
-              <a:t>Cada casa exige reed switch, diodo e solda. O esforço cresce linearmente e não paraleliza bem entre os integrantes.</a:t>
-            </a:r>
-          </a:p>
-        </p:txBody>
-      </p:sp>
-      <p:sp>
-        <p:nvSpPr>
-          <p:cNvPr id="9" name="Rectangle 8"/>
-          <p:cNvSpPr/>
-          <p:nvPr/>
-        </p:nvSpPr>
-        <p:spPr>
-          <a:xfrm>
-            <a:off x="685800" y="3712464"/>
-            <a:ext cx="44450" cy="658368"/>
-          </a:xfrm>
-          <a:prstGeom prst="rect">
-            <a:avLst/>
-          </a:prstGeom>
-          <a:solidFill>
-            <a:srgbClr val="E2B714"/>
-          </a:solidFill>
-          <a:ln>
-            <a:noFill/>
-          </a:ln>
-          <a:effectLst/>
-        </p:spPr>
-        <p:style>
-          <a:lnRef idx="1">
-            <a:schemeClr val="accent1"/>
-          </a:lnRef>
-          <a:fillRef idx="3">
-            <a:schemeClr val="accent1"/>
-          </a:fillRef>
-          <a:effectRef idx="2">
-            <a:schemeClr val="accent1"/>
-          </a:effectRef>
-          <a:fontRef idx="minor">
-            <a:schemeClr val="lt1"/>
-          </a:fontRef>
-        </p:style>
-        <p:txBody>
-          <a:bodyPr rtlCol="0" anchor="ctr"/>
-          <a:lstStyle/>
-          <a:p>
-            <a:pPr algn="ctr"/>
-          </a:p>
-        </p:txBody>
-      </p:sp>
-      <p:sp>
-        <p:nvSpPr>
-          <p:cNvPr id="10" name="TextBox 9"/>
-          <p:cNvSpPr txBox="1"/>
-          <p:nvPr/>
-        </p:nvSpPr>
-        <p:spPr>
-          <a:xfrm>
-            <a:off x="941832" y="3657600"/>
-            <a:ext cx="10564063" cy="822960"/>
-          </a:xfrm>
-          <a:prstGeom prst="rect">
-            <a:avLst/>
-          </a:prstGeom>
-          <a:noFill/>
-        </p:spPr>
-        <p:txBody>
-          <a:bodyPr wrap="square" lIns="0" rIns="0" tIns="0" bIns="0">
-            <a:spAutoFit/>
-          </a:bodyPr>
-          <a:lstStyle/>
-          <a:p>
-            <a:pPr algn="l">
-              <a:spcAft>
-                <a:spcPts val="200"/>
-              </a:spcAft>
-            </a:pPr>
-            <a:r>
-              <a:rPr sz="1700" b="1">
-                <a:solidFill>
-                  <a:srgbClr val="F2F4F8"/>
-                </a:solidFill>
-              </a:rPr>
-              <a:t>Tabuleiro físico e tabuleiro virtual divergem</a:t>
-            </a:r>
-          </a:p>
-          <a:p>
-            <a:pPr algn="l">
-              <a:spcAft>
-                <a:spcPts val="0"/>
-              </a:spcAft>
-            </a:pPr>
-            <a:r>
-              <a:rPr sz="1300" b="0">
-                <a:solidFill>
-                  <a:srgbClr val="D6DEE8"/>
-                </a:solidFill>
-              </a:rPr>
-              <a:t>Reed switches dizem onde há ímã, não qual peça é. Capturas do oponente e lances ilegais dessincronizam os dois — resolvido com histórico de peças deslocadas, instruções explícitas na barra de status e comandos de ressincronização.</a:t>
-            </a:r>
-          </a:p>
-        </p:txBody>
-      </p:sp>
-      <p:sp>
-        <p:nvSpPr>
-          <p:cNvPr id="11" name="Rectangle 10"/>
-          <p:cNvSpPr/>
-          <p:nvPr/>
-        </p:nvSpPr>
-        <p:spPr>
-          <a:xfrm>
-            <a:off x="685800" y="4672584"/>
-            <a:ext cx="44450" cy="658368"/>
-          </a:xfrm>
-          <a:prstGeom prst="rect">
-            <a:avLst/>
-          </a:prstGeom>
-          <a:solidFill>
-            <a:srgbClr val="E2B714"/>
-          </a:solidFill>
-          <a:ln>
-            <a:noFill/>
-          </a:ln>
-          <a:effectLst/>
-        </p:spPr>
-        <p:style>
-          <a:lnRef idx="1">
-            <a:schemeClr val="accent1"/>
-          </a:lnRef>
-          <a:fillRef idx="3">
-            <a:schemeClr val="accent1"/>
-          </a:fillRef>
-          <a:effectRef idx="2">
-            <a:schemeClr val="accent1"/>
-          </a:effectRef>
-          <a:fontRef idx="minor">
-            <a:schemeClr val="lt1"/>
-          </a:fontRef>
-        </p:style>
-        <p:txBody>
-          <a:bodyPr rtlCol="0" anchor="ctr"/>
-          <a:lstStyle/>
-          <a:p>
-            <a:pPr algn="ctr"/>
-          </a:p>
-        </p:txBody>
-      </p:sp>
-      <p:sp>
-        <p:nvSpPr>
-          <p:cNvPr id="12" name="TextBox 11"/>
-          <p:cNvSpPr txBox="1"/>
-          <p:nvPr/>
-        </p:nvSpPr>
-        <p:spPr>
-          <a:xfrm>
-            <a:off x="941832" y="4617720"/>
-            <a:ext cx="10564063" cy="822960"/>
-          </a:xfrm>
-          <a:prstGeom prst="rect">
-            <a:avLst/>
-          </a:prstGeom>
-          <a:noFill/>
-        </p:spPr>
-        <p:txBody>
-          <a:bodyPr wrap="square" lIns="0" rIns="0" tIns="0" bIns="0">
-            <a:spAutoFit/>
-          </a:bodyPr>
-          <a:lstStyle/>
-          <a:p>
-            <a:pPr algn="l">
-              <a:spcAft>
-                <a:spcPts val="200"/>
-              </a:spcAft>
-            </a:pPr>
-            <a:r>
-              <a:rPr sz="1700" b="1">
-                <a:solidFill>
-                  <a:srgbClr val="F2F4F8"/>
-                </a:solidFill>
-              </a:rPr>
-              <a:t>Restrições da Board API</a:t>
-            </a:r>
-          </a:p>
-          <a:p>
-            <a:pPr algn="l">
-              <a:spcAft>
-                <a:spcPts val="0"/>
-              </a:spcAft>
-            </a:pPr>
-            <a:r>
-              <a:rPr sz="1300" b="0">
-                <a:solidFill>
-                  <a:srgbClr val="D6DEE8"/>
-                </a:solidFill>
-              </a:rPr>
-              <a:t>O Lichess recusa controles de tempo abaixo de 480 s estimados. Descoberto empiricamente e transformado em verificação prévia, com explicação, em vez de um HTTP 400 sem contexto.</a:t>
-            </a:r>
-          </a:p>
-        </p:txBody>
-      </p:sp>
-      <p:sp>
-        <p:nvSpPr>
-          <p:cNvPr id="13" name="Rectangle 12"/>
-          <p:cNvSpPr/>
-          <p:nvPr/>
-        </p:nvSpPr>
-        <p:spPr>
-          <a:xfrm>
-            <a:off x="685800" y="5632704"/>
-            <a:ext cx="44450" cy="658368"/>
-          </a:xfrm>
-          <a:prstGeom prst="rect">
-            <a:avLst/>
-          </a:prstGeom>
-          <a:solidFill>
-            <a:srgbClr val="E2B714"/>
-          </a:solidFill>
-          <a:ln>
-            <a:noFill/>
-          </a:ln>
-          <a:effectLst/>
-        </p:spPr>
-        <p:style>
-          <a:lnRef idx="1">
-            <a:schemeClr val="accent1"/>
-          </a:lnRef>
-          <a:fillRef idx="3">
-            <a:schemeClr val="accent1"/>
-          </a:fillRef>
-          <a:effectRef idx="2">
-            <a:schemeClr val="accent1"/>
-          </a:effectRef>
-          <a:fontRef idx="minor">
-            <a:schemeClr val="lt1"/>
-          </a:fontRef>
-        </p:style>
-        <p:txBody>
-          <a:bodyPr rtlCol="0" anchor="ctr"/>
-          <a:lstStyle/>
-          <a:p>
-            <a:pPr algn="ctr"/>
-          </a:p>
-        </p:txBody>
-      </p:sp>
-      <p:sp>
-        <p:nvSpPr>
-          <p:cNvPr id="14" name="TextBox 13"/>
-          <p:cNvSpPr txBox="1"/>
-          <p:nvPr/>
-        </p:nvSpPr>
-        <p:spPr>
-          <a:xfrm>
-            <a:off x="941832" y="5577840"/>
-            <a:ext cx="10564063" cy="822960"/>
-          </a:xfrm>
-          <a:prstGeom prst="rect">
-            <a:avLst/>
-          </a:prstGeom>
-          <a:noFill/>
-        </p:spPr>
-        <p:txBody>
-          <a:bodyPr wrap="square" lIns="0" rIns="0" tIns="0" bIns="0">
-            <a:spAutoFit/>
-          </a:bodyPr>
-          <a:lstStyle/>
-          <a:p>
-            <a:pPr algn="l">
-              <a:spcAft>
-                <a:spcPts val="200"/>
-              </a:spcAft>
-            </a:pPr>
-            <a:r>
-              <a:rPr sz="1700" b="1">
-                <a:solidFill>
-                  <a:srgbClr val="F2F4F8"/>
-                </a:solidFill>
-              </a:rPr>
-              <a:t>Testar hardware que ainda não existe</a:t>
-            </a:r>
-          </a:p>
-          <a:p>
-            <a:pPr algn="l">
-              <a:spcAft>
-                <a:spcPts val="0"/>
-              </a:spcAft>
-            </a:pPr>
-            <a:r>
-              <a:rPr sz="1300" b="0">
-                <a:solidFill>
-                  <a:srgbClr val="D6DEE8"/>
-                </a:solidFill>
-              </a:rPr>
-              <a:t>Resolvido com mock gráfico dos sensores, stubs de GPIO que permitem compilar o binário fora do Raspberry Pi e um servidor falso da Board API.</a:t>
+              <a:rPr sz="1100" b="0">
+                <a:solidFill>
+                  <a:srgbClr val="9FB3C8"/>
+                </a:solidFill>
+              </a:rPr>
+              <a:t>As pendências são de medição, não de implementação: exigem instrumentar o caminho completo no Raspberry Pi.</a:t>
             </a:r>
           </a:p>
         </p:txBody>
@@ -8627,7 +8483,7 @@
                   <a:srgbClr val="F2F4F8"/>
                 </a:solidFill>
               </a:rPr>
-              <a:t>Trabalhos futuros</a:t>
+              <a:t>Dificuldades encontradas</a:t>
             </a:r>
           </a:p>
           <a:p>
@@ -8642,7 +8498,7 @@
                   <a:srgbClr val="9FB3C8"/>
                 </a:solidFill>
               </a:rPr>
-              <a:t>O que fica encaminhado</a:t>
+              <a:t>O que custou tempo e o que aprendemos</a:t>
             </a:r>
           </a:p>
         </p:txBody>
@@ -8693,344 +8549,58 @@
       </p:sp>
       <p:sp>
         <p:nvSpPr>
-          <p:cNvPr id="5" name="Rounded Rectangle 4"/>
-          <p:cNvSpPr/>
-          <p:nvPr/>
-        </p:nvSpPr>
-        <p:spPr>
-          <a:xfrm>
-            <a:off x="685800" y="1783080"/>
-            <a:ext cx="3429000" cy="2834640"/>
-          </a:xfrm>
-          <a:prstGeom prst="roundRect">
-            <a:avLst>
-              <a:gd name="adj" fmla="val 6000"/>
-            </a:avLst>
-          </a:prstGeom>
-          <a:solidFill>
-            <a:srgbClr val="172740"/>
-          </a:solidFill>
-          <a:ln w="15875">
-            <a:solidFill>
-              <a:srgbClr val="E94560"/>
-            </a:solidFill>
-          </a:ln>
-          <a:effectLst/>
-        </p:spPr>
-        <p:style>
-          <a:lnRef idx="1">
-            <a:schemeClr val="accent1"/>
-          </a:lnRef>
-          <a:fillRef idx="3">
-            <a:schemeClr val="accent1"/>
-          </a:fillRef>
-          <a:effectRef idx="2">
-            <a:schemeClr val="accent1"/>
-          </a:effectRef>
-          <a:fontRef idx="minor">
-            <a:schemeClr val="lt1"/>
-          </a:fontRef>
-        </p:style>
-        <p:txBody>
-          <a:bodyPr rtlCol="0" anchor="t" wrap="square" lIns="201168" rIns="201168" tIns="164592" bIns="164592"/>
-          <a:lstStyle/>
-          <a:p>
-            <a:pPr algn="l">
-              <a:spcAft>
-                <a:spcPts val="600"/>
-              </a:spcAft>
-            </a:pPr>
-            <a:r>
-              <a:rPr sz="1700" b="1">
-                <a:solidFill>
-                  <a:srgbClr val="E94560"/>
-                </a:solidFill>
-              </a:rPr>
-              <a:t>Hardware</a:t>
-            </a:r>
-          </a:p>
-          <a:p>
-            <a:pPr algn="l">
-              <a:spcAft>
-                <a:spcPts val="400"/>
-              </a:spcAft>
-            </a:pPr>
-            <a:r>
-              <a:rPr sz="1300" b="0">
-                <a:solidFill>
-                  <a:srgbClr val="D6DEE8"/>
-                </a:solidFill>
-              </a:rPr>
-              <a:t>Concluir as 64 casas do tabuleiro com chapa de espessura adequada</a:t>
-            </a:r>
-          </a:p>
-          <a:p>
-            <a:pPr algn="l">
-              <a:spcAft>
-                <a:spcPts val="400"/>
-              </a:spcAft>
-            </a:pPr>
-            <a:r>
-              <a:rPr sz="1300" b="0">
-                <a:solidFill>
-                  <a:srgbClr val="D6DEE8"/>
-                </a:solidFill>
-              </a:rPr>
-              <a:t>Medir a taxa de acerto da detecção e exercitar o debouncing com esbarrões reais (RNF3)</a:t>
-            </a:r>
-          </a:p>
-          <a:p>
-            <a:pPr algn="l">
-              <a:spcAft>
-                <a:spcPts val="400"/>
-              </a:spcAft>
-            </a:pPr>
-            <a:r>
-              <a:rPr sz="1300" b="0">
-                <a:solidFill>
-                  <a:srgbClr val="D6DEE8"/>
-                </a:solidFill>
-              </a:rPr>
-              <a:t>Integrar o display 16×2 por I²C ao caminho principal</a:t>
-            </a:r>
-          </a:p>
-        </p:txBody>
-      </p:sp>
-      <p:sp>
-        <p:nvSpPr>
-          <p:cNvPr id="6" name="Rounded Rectangle 5"/>
-          <p:cNvSpPr/>
-          <p:nvPr/>
-        </p:nvSpPr>
-        <p:spPr>
-          <a:xfrm>
-            <a:off x="4480560" y="1783080"/>
-            <a:ext cx="3429000" cy="2834640"/>
-          </a:xfrm>
-          <a:prstGeom prst="roundRect">
-            <a:avLst>
-              <a:gd name="adj" fmla="val 6000"/>
-            </a:avLst>
-          </a:prstGeom>
-          <a:solidFill>
-            <a:srgbClr val="172740"/>
-          </a:solidFill>
-          <a:ln w="15875">
-            <a:solidFill>
-              <a:srgbClr val="E2B714"/>
-            </a:solidFill>
-          </a:ln>
-          <a:effectLst/>
-        </p:spPr>
-        <p:style>
-          <a:lnRef idx="1">
-            <a:schemeClr val="accent1"/>
-          </a:lnRef>
-          <a:fillRef idx="3">
-            <a:schemeClr val="accent1"/>
-          </a:fillRef>
-          <a:effectRef idx="2">
-            <a:schemeClr val="accent1"/>
-          </a:effectRef>
-          <a:fontRef idx="minor">
-            <a:schemeClr val="lt1"/>
-          </a:fontRef>
-        </p:style>
-        <p:txBody>
-          <a:bodyPr rtlCol="0" anchor="t" wrap="square" lIns="201168" rIns="201168" tIns="164592" bIns="164592"/>
-          <a:lstStyle/>
-          <a:p>
-            <a:pPr algn="l">
-              <a:spcAft>
-                <a:spcPts val="600"/>
-              </a:spcAft>
-            </a:pPr>
-            <a:r>
-              <a:rPr sz="1700" b="1">
-                <a:solidFill>
-                  <a:srgbClr val="E2B714"/>
-                </a:solidFill>
-              </a:rPr>
-              <a:t>Medição</a:t>
-            </a:r>
-          </a:p>
-          <a:p>
-            <a:pPr algn="l">
-              <a:spcAft>
-                <a:spcPts val="400"/>
-              </a:spcAft>
-            </a:pPr>
-            <a:r>
-              <a:rPr sz="1300" b="0">
-                <a:solidFill>
-                  <a:srgbClr val="D6DEE8"/>
-                </a:solidFill>
-              </a:rPr>
-              <a:t>Instrumentar o caminho completo — sensor ou tecla até o quadro renderizado — no próprio Raspberry Pi</a:t>
-            </a:r>
-          </a:p>
-          <a:p>
-            <a:pPr algn="l">
-              <a:spcAft>
-                <a:spcPts val="400"/>
-              </a:spcAft>
-            </a:pPr>
-            <a:r>
-              <a:rPr sz="1300" b="0">
-                <a:solidFill>
-                  <a:srgbClr val="D6DEE8"/>
-                </a:solidFill>
-              </a:rPr>
-              <a:t>Fechar as evidências de RNF1 (&lt; 200 ms) e RNF2 (&lt; 100 ms)</a:t>
-            </a:r>
-          </a:p>
-          <a:p>
-            <a:pPr algn="l">
-              <a:spcAft>
-                <a:spcPts val="400"/>
-              </a:spcAft>
-            </a:pPr>
-            <a:r>
-              <a:rPr sz="1300" b="0">
-                <a:solidFill>
-                  <a:srgbClr val="D6DEE8"/>
-                </a:solidFill>
-              </a:rPr>
-              <a:t>Teste de aceitação: partidas completas até o xeque-mate</a:t>
-            </a:r>
-          </a:p>
-        </p:txBody>
-      </p:sp>
-      <p:sp>
-        <p:nvSpPr>
-          <p:cNvPr id="7" name="Rounded Rectangle 6"/>
-          <p:cNvSpPr/>
-          <p:nvPr/>
-        </p:nvSpPr>
-        <p:spPr>
-          <a:xfrm>
-            <a:off x="8275320" y="1783080"/>
-            <a:ext cx="3429000" cy="2834640"/>
-          </a:xfrm>
-          <a:prstGeom prst="roundRect">
-            <a:avLst>
-              <a:gd name="adj" fmla="val 6000"/>
-            </a:avLst>
-          </a:prstGeom>
-          <a:solidFill>
-            <a:srgbClr val="172740"/>
-          </a:solidFill>
-          <a:ln w="15875">
-            <a:solidFill>
-              <a:srgbClr val="4CC38A"/>
-            </a:solidFill>
-          </a:ln>
-          <a:effectLst/>
-        </p:spPr>
-        <p:style>
-          <a:lnRef idx="1">
-            <a:schemeClr val="accent1"/>
-          </a:lnRef>
-          <a:fillRef idx="3">
-            <a:schemeClr val="accent1"/>
-          </a:fillRef>
-          <a:effectRef idx="2">
-            <a:schemeClr val="accent1"/>
-          </a:effectRef>
-          <a:fontRef idx="minor">
-            <a:schemeClr val="lt1"/>
-          </a:fontRef>
-        </p:style>
-        <p:txBody>
-          <a:bodyPr rtlCol="0" anchor="t" wrap="square" lIns="201168" rIns="201168" tIns="164592" bIns="164592"/>
-          <a:lstStyle/>
-          <a:p>
-            <a:pPr algn="l">
-              <a:spcAft>
-                <a:spcPts val="600"/>
-              </a:spcAft>
-            </a:pPr>
-            <a:r>
-              <a:rPr sz="1700" b="1">
-                <a:solidFill>
-                  <a:srgbClr val="4CC38A"/>
-                </a:solidFill>
-              </a:rPr>
-              <a:t>Software</a:t>
-            </a:r>
-          </a:p>
-          <a:p>
-            <a:pPr algn="l">
-              <a:spcAft>
-                <a:spcPts val="400"/>
-              </a:spcAft>
-            </a:pPr>
-            <a:r>
-              <a:rPr sz="1300" b="0">
-                <a:solidFill>
-                  <a:srgbClr val="D6DEE8"/>
-                </a:solidFill>
-              </a:rPr>
-              <a:t>Envio de lances ao Lichess fora do loop principal (hoje é POST síncrono)</a:t>
-            </a:r>
-          </a:p>
-          <a:p>
-            <a:pPr algn="l">
-              <a:spcAft>
-                <a:spcPts val="400"/>
-              </a:spcAft>
-            </a:pPr>
-            <a:r>
-              <a:rPr sz="1300" b="0">
-                <a:solidFill>
-                  <a:srgbClr val="D6DEE8"/>
-                </a:solidFill>
-              </a:rPr>
-              <a:t>Reconexão automática do stream e reconstrução do estado após takeback</a:t>
-            </a:r>
-          </a:p>
-          <a:p>
-            <a:pPr algn="l">
-              <a:spcAft>
-                <a:spcPts val="400"/>
-              </a:spcAft>
-            </a:pPr>
-            <a:r>
-              <a:rPr sz="1300" b="0">
-                <a:solidFill>
-                  <a:srgbClr val="D6DEE8"/>
-                </a:solidFill>
-              </a:rPr>
-              <a:t>Diálogo de promoção (hoje promove sempre para dama)</a:t>
-            </a:r>
-          </a:p>
-          <a:p>
-            <a:pPr algn="l">
-              <a:spcAft>
-                <a:spcPts val="400"/>
-              </a:spcAft>
-            </a:pPr>
-            <a:r>
-              <a:rPr sz="1300" b="0">
-                <a:solidFill>
-                  <a:srgbClr val="D6DEE8"/>
-                </a:solidFill>
-              </a:rPr>
-              <a:t>Relógios da partida e suporte a variantes</a:t>
-            </a:r>
-          </a:p>
-        </p:txBody>
-      </p:sp>
-      <p:sp>
-        <p:nvSpPr>
-          <p:cNvPr id="8" name="TextBox 7"/>
+          <p:cNvPr id="5" name="Rectangle 4"/>
+          <p:cNvSpPr/>
+          <p:nvPr/>
+        </p:nvSpPr>
+        <p:spPr>
+          <a:xfrm>
+            <a:off x="685800" y="1792224"/>
+            <a:ext cx="44450" cy="658368"/>
+          </a:xfrm>
+          <a:prstGeom prst="rect">
+            <a:avLst/>
+          </a:prstGeom>
+          <a:solidFill>
+            <a:srgbClr val="E2B714"/>
+          </a:solidFill>
+          <a:ln>
+            <a:noFill/>
+          </a:ln>
+          <a:effectLst/>
+        </p:spPr>
+        <p:style>
+          <a:lnRef idx="1">
+            <a:schemeClr val="accent1"/>
+          </a:lnRef>
+          <a:fillRef idx="3">
+            <a:schemeClr val="accent1"/>
+          </a:fillRef>
+          <a:effectRef idx="2">
+            <a:schemeClr val="accent1"/>
+          </a:effectRef>
+          <a:fontRef idx="minor">
+            <a:schemeClr val="lt1"/>
+          </a:fontRef>
+        </p:style>
+        <p:txBody>
+          <a:bodyPr rtlCol="0" anchor="ctr"/>
+          <a:lstStyle/>
+          <a:p>
+            <a:pPr algn="ctr"/>
+          </a:p>
+        </p:txBody>
+      </p:sp>
+      <p:sp>
+        <p:nvSpPr>
+          <p:cNvPr id="6" name="TextBox 5"/>
           <p:cNvSpPr txBox="1"/>
           <p:nvPr/>
         </p:nvSpPr>
         <p:spPr>
           <a:xfrm>
-            <a:off x="685800" y="4937760"/>
-            <a:ext cx="10820095" cy="1280160"/>
+            <a:off x="941832" y="1737360"/>
+            <a:ext cx="10564063" cy="822960"/>
           </a:xfrm>
           <a:prstGeom prst="rect">
             <a:avLst/>
@@ -9045,16 +8615,16 @@
           <a:p>
             <a:pPr algn="l">
               <a:spcAft>
-                <a:spcPts val="800"/>
-              </a:spcAft>
-            </a:pPr>
-            <a:r>
-              <a:rPr sz="1900" b="1">
+                <a:spcPts val="200"/>
+              </a:spcAft>
+            </a:pPr>
+            <a:r>
+              <a:rPr sz="1700" b="1">
                 <a:solidFill>
                   <a:srgbClr val="F2F4F8"/>
                 </a:solidFill>
               </a:rPr>
-              <a:t>Considerações finais</a:t>
+              <a:t>Mecânica antes da eletrônica</a:t>
             </a:r>
           </a:p>
           <a:p>
@@ -9064,12 +8634,400 @@
               </a:spcAft>
             </a:pPr>
             <a:r>
-              <a:rPr sz="1500" b="0">
+              <a:rPr sz="1300" b="0">
                 <a:solidFill>
                   <a:srgbClr val="D6DEE8"/>
                 </a:solidFill>
               </a:rPr>
-              <a:t>O sistema está jogável de ponta a ponta — contra o Stockfish e contra oponentes online — com toda a lógica de xadrez, a interface e a integração validadas por testes automatizados. O que separa o projeto do escopo original é a montagem física do tabuleiro, e a decisão de manter as camadas de entrada intercambiáveis foi o que permitiu que esse atraso não bloqueasse o resto.</a:t>
+              <a:t>A chapa de acrílico escolhida ficou espessa demais para o alcance dos ímãs de neodímio. Um detalhe mecânico — não de software nem de circuito — foi o que travou o cronograma do hardware.</a:t>
+            </a:r>
+          </a:p>
+        </p:txBody>
+      </p:sp>
+      <p:sp>
+        <p:nvSpPr>
+          <p:cNvPr id="7" name="Rectangle 6"/>
+          <p:cNvSpPr/>
+          <p:nvPr/>
+        </p:nvSpPr>
+        <p:spPr>
+          <a:xfrm>
+            <a:off x="685800" y="2752344"/>
+            <a:ext cx="44450" cy="658368"/>
+          </a:xfrm>
+          <a:prstGeom prst="rect">
+            <a:avLst/>
+          </a:prstGeom>
+          <a:solidFill>
+            <a:srgbClr val="E2B714"/>
+          </a:solidFill>
+          <a:ln>
+            <a:noFill/>
+          </a:ln>
+          <a:effectLst/>
+        </p:spPr>
+        <p:style>
+          <a:lnRef idx="1">
+            <a:schemeClr val="accent1"/>
+          </a:lnRef>
+          <a:fillRef idx="3">
+            <a:schemeClr val="accent1"/>
+          </a:fillRef>
+          <a:effectRef idx="2">
+            <a:schemeClr val="accent1"/>
+          </a:effectRef>
+          <a:fontRef idx="minor">
+            <a:schemeClr val="lt1"/>
+          </a:fontRef>
+        </p:style>
+        <p:txBody>
+          <a:bodyPr rtlCol="0" anchor="ctr"/>
+          <a:lstStyle/>
+          <a:p>
+            <a:pPr algn="ctr"/>
+          </a:p>
+        </p:txBody>
+      </p:sp>
+      <p:sp>
+        <p:nvSpPr>
+          <p:cNvPr id="8" name="TextBox 7"/>
+          <p:cNvSpPr txBox="1"/>
+          <p:nvPr/>
+        </p:nvSpPr>
+        <p:spPr>
+          <a:xfrm>
+            <a:off x="941832" y="2697480"/>
+            <a:ext cx="10564063" cy="822960"/>
+          </a:xfrm>
+          <a:prstGeom prst="rect">
+            <a:avLst/>
+          </a:prstGeom>
+          <a:noFill/>
+        </p:spPr>
+        <p:txBody>
+          <a:bodyPr wrap="square" lIns="0" rIns="0" tIns="0" bIns="0">
+            <a:spAutoFit/>
+          </a:bodyPr>
+          <a:lstStyle/>
+          <a:p>
+            <a:pPr algn="l">
+              <a:spcAft>
+                <a:spcPts val="200"/>
+              </a:spcAft>
+            </a:pPr>
+            <a:r>
+              <a:rPr sz="1700" b="1">
+                <a:solidFill>
+                  <a:srgbClr val="F2F4F8"/>
+                </a:solidFill>
+              </a:rPr>
+              <a:t>Montagem de 64 casas é trabalho manual</a:t>
+            </a:r>
+          </a:p>
+          <a:p>
+            <a:pPr algn="l">
+              <a:spcAft>
+                <a:spcPts val="0"/>
+              </a:spcAft>
+            </a:pPr>
+            <a:r>
+              <a:rPr sz="1300" b="0">
+                <a:solidFill>
+                  <a:srgbClr val="D6DEE8"/>
+                </a:solidFill>
+              </a:rPr>
+              <a:t>Cada casa exige reed switch, diodo e solda. O esforço cresce linearmente e não paraleliza bem entre os integrantes.</a:t>
+            </a:r>
+          </a:p>
+        </p:txBody>
+      </p:sp>
+      <p:sp>
+        <p:nvSpPr>
+          <p:cNvPr id="9" name="Rectangle 8"/>
+          <p:cNvSpPr/>
+          <p:nvPr/>
+        </p:nvSpPr>
+        <p:spPr>
+          <a:xfrm>
+            <a:off x="685800" y="3712464"/>
+            <a:ext cx="44450" cy="658368"/>
+          </a:xfrm>
+          <a:prstGeom prst="rect">
+            <a:avLst/>
+          </a:prstGeom>
+          <a:solidFill>
+            <a:srgbClr val="E2B714"/>
+          </a:solidFill>
+          <a:ln>
+            <a:noFill/>
+          </a:ln>
+          <a:effectLst/>
+        </p:spPr>
+        <p:style>
+          <a:lnRef idx="1">
+            <a:schemeClr val="accent1"/>
+          </a:lnRef>
+          <a:fillRef idx="3">
+            <a:schemeClr val="accent1"/>
+          </a:fillRef>
+          <a:effectRef idx="2">
+            <a:schemeClr val="accent1"/>
+          </a:effectRef>
+          <a:fontRef idx="minor">
+            <a:schemeClr val="lt1"/>
+          </a:fontRef>
+        </p:style>
+        <p:txBody>
+          <a:bodyPr rtlCol="0" anchor="ctr"/>
+          <a:lstStyle/>
+          <a:p>
+            <a:pPr algn="ctr"/>
+          </a:p>
+        </p:txBody>
+      </p:sp>
+      <p:sp>
+        <p:nvSpPr>
+          <p:cNvPr id="10" name="TextBox 9"/>
+          <p:cNvSpPr txBox="1"/>
+          <p:nvPr/>
+        </p:nvSpPr>
+        <p:spPr>
+          <a:xfrm>
+            <a:off x="941832" y="3657600"/>
+            <a:ext cx="10564063" cy="822960"/>
+          </a:xfrm>
+          <a:prstGeom prst="rect">
+            <a:avLst/>
+          </a:prstGeom>
+          <a:noFill/>
+        </p:spPr>
+        <p:txBody>
+          <a:bodyPr wrap="square" lIns="0" rIns="0" tIns="0" bIns="0">
+            <a:spAutoFit/>
+          </a:bodyPr>
+          <a:lstStyle/>
+          <a:p>
+            <a:pPr algn="l">
+              <a:spcAft>
+                <a:spcPts val="200"/>
+              </a:spcAft>
+            </a:pPr>
+            <a:r>
+              <a:rPr sz="1700" b="1">
+                <a:solidFill>
+                  <a:srgbClr val="F2F4F8"/>
+                </a:solidFill>
+              </a:rPr>
+              <a:t>Tabuleiro físico e tabuleiro virtual divergem</a:t>
+            </a:r>
+          </a:p>
+          <a:p>
+            <a:pPr algn="l">
+              <a:spcAft>
+                <a:spcPts val="0"/>
+              </a:spcAft>
+            </a:pPr>
+            <a:r>
+              <a:rPr sz="1300" b="0">
+                <a:solidFill>
+                  <a:srgbClr val="D6DEE8"/>
+                </a:solidFill>
+              </a:rPr>
+              <a:t>Reed switches dizem onde há ímã, não qual peça é. Capturas do oponente e lances ilegais dessincronizam os dois — resolvido com histórico de peças deslocadas, instruções na barra de status, ressincronização e canal @sync bidirecional para a camada de teclado.</a:t>
+            </a:r>
+          </a:p>
+        </p:txBody>
+      </p:sp>
+      <p:sp>
+        <p:nvSpPr>
+          <p:cNvPr id="11" name="Rectangle 10"/>
+          <p:cNvSpPr/>
+          <p:nvPr/>
+        </p:nvSpPr>
+        <p:spPr>
+          <a:xfrm>
+            <a:off x="685800" y="4672584"/>
+            <a:ext cx="44450" cy="658368"/>
+          </a:xfrm>
+          <a:prstGeom prst="rect">
+            <a:avLst/>
+          </a:prstGeom>
+          <a:solidFill>
+            <a:srgbClr val="E2B714"/>
+          </a:solidFill>
+          <a:ln>
+            <a:noFill/>
+          </a:ln>
+          <a:effectLst/>
+        </p:spPr>
+        <p:style>
+          <a:lnRef idx="1">
+            <a:schemeClr val="accent1"/>
+          </a:lnRef>
+          <a:fillRef idx="3">
+            <a:schemeClr val="accent1"/>
+          </a:fillRef>
+          <a:effectRef idx="2">
+            <a:schemeClr val="accent1"/>
+          </a:effectRef>
+          <a:fontRef idx="minor">
+            <a:schemeClr val="lt1"/>
+          </a:fontRef>
+        </p:style>
+        <p:txBody>
+          <a:bodyPr rtlCol="0" anchor="ctr"/>
+          <a:lstStyle/>
+          <a:p>
+            <a:pPr algn="ctr"/>
+          </a:p>
+        </p:txBody>
+      </p:sp>
+      <p:sp>
+        <p:nvSpPr>
+          <p:cNvPr id="12" name="TextBox 11"/>
+          <p:cNvSpPr txBox="1"/>
+          <p:nvPr/>
+        </p:nvSpPr>
+        <p:spPr>
+          <a:xfrm>
+            <a:off x="941832" y="4617720"/>
+            <a:ext cx="10564063" cy="822960"/>
+          </a:xfrm>
+          <a:prstGeom prst="rect">
+            <a:avLst/>
+          </a:prstGeom>
+          <a:noFill/>
+        </p:spPr>
+        <p:txBody>
+          <a:bodyPr wrap="square" lIns="0" rIns="0" tIns="0" bIns="0">
+            <a:spAutoFit/>
+          </a:bodyPr>
+          <a:lstStyle/>
+          <a:p>
+            <a:pPr algn="l">
+              <a:spcAft>
+                <a:spcPts val="200"/>
+              </a:spcAft>
+            </a:pPr>
+            <a:r>
+              <a:rPr sz="1700" b="1">
+                <a:solidFill>
+                  <a:srgbClr val="F2F4F8"/>
+                </a:solidFill>
+              </a:rPr>
+              <a:t>Restrições da Board API</a:t>
+            </a:r>
+          </a:p>
+          <a:p>
+            <a:pPr algn="l">
+              <a:spcAft>
+                <a:spcPts val="0"/>
+              </a:spcAft>
+            </a:pPr>
+            <a:r>
+              <a:rPr sz="1300" b="0">
+                <a:solidFill>
+                  <a:srgbClr val="D6DEE8"/>
+                </a:solidFill>
+              </a:rPr>
+              <a:t>O Lichess recusa controles de tempo abaixo de 480 s estimados. Descoberto empiricamente e transformado em verificação prévia, com explicação, em vez de um HTTP 400 sem contexto.</a:t>
+            </a:r>
+          </a:p>
+        </p:txBody>
+      </p:sp>
+      <p:sp>
+        <p:nvSpPr>
+          <p:cNvPr id="13" name="Rectangle 12"/>
+          <p:cNvSpPr/>
+          <p:nvPr/>
+        </p:nvSpPr>
+        <p:spPr>
+          <a:xfrm>
+            <a:off x="685800" y="5632704"/>
+            <a:ext cx="44450" cy="658368"/>
+          </a:xfrm>
+          <a:prstGeom prst="rect">
+            <a:avLst/>
+          </a:prstGeom>
+          <a:solidFill>
+            <a:srgbClr val="E2B714"/>
+          </a:solidFill>
+          <a:ln>
+            <a:noFill/>
+          </a:ln>
+          <a:effectLst/>
+        </p:spPr>
+        <p:style>
+          <a:lnRef idx="1">
+            <a:schemeClr val="accent1"/>
+          </a:lnRef>
+          <a:fillRef idx="3">
+            <a:schemeClr val="accent1"/>
+          </a:fillRef>
+          <a:effectRef idx="2">
+            <a:schemeClr val="accent1"/>
+          </a:effectRef>
+          <a:fontRef idx="minor">
+            <a:schemeClr val="lt1"/>
+          </a:fontRef>
+        </p:style>
+        <p:txBody>
+          <a:bodyPr rtlCol="0" anchor="ctr"/>
+          <a:lstStyle/>
+          <a:p>
+            <a:pPr algn="ctr"/>
+          </a:p>
+        </p:txBody>
+      </p:sp>
+      <p:sp>
+        <p:nvSpPr>
+          <p:cNvPr id="14" name="TextBox 13"/>
+          <p:cNvSpPr txBox="1"/>
+          <p:nvPr/>
+        </p:nvSpPr>
+        <p:spPr>
+          <a:xfrm>
+            <a:off x="941832" y="5577840"/>
+            <a:ext cx="10564063" cy="822960"/>
+          </a:xfrm>
+          <a:prstGeom prst="rect">
+            <a:avLst/>
+          </a:prstGeom>
+          <a:noFill/>
+        </p:spPr>
+        <p:txBody>
+          <a:bodyPr wrap="square" lIns="0" rIns="0" tIns="0" bIns="0">
+            <a:spAutoFit/>
+          </a:bodyPr>
+          <a:lstStyle/>
+          <a:p>
+            <a:pPr algn="l">
+              <a:spcAft>
+                <a:spcPts val="200"/>
+              </a:spcAft>
+            </a:pPr>
+            <a:r>
+              <a:rPr sz="1700" b="1">
+                <a:solidFill>
+                  <a:srgbClr val="F2F4F8"/>
+                </a:solidFill>
+              </a:rPr>
+              <a:t>Testar hardware que ainda não existe</a:t>
+            </a:r>
+          </a:p>
+          <a:p>
+            <a:pPr algn="l">
+              <a:spcAft>
+                <a:spcPts val="0"/>
+              </a:spcAft>
+            </a:pPr>
+            <a:r>
+              <a:rPr sz="1300" b="0">
+                <a:solidFill>
+                  <a:srgbClr val="D6DEE8"/>
+                </a:solidFill>
+              </a:rPr>
+              <a:t>Resolvido com mock gráfico dos sensores, stubs de GPIO que permitem compilar o binário fora do Raspberry Pi e um servidor falso da Board API.</a:t>
             </a:r>
           </a:p>
         </p:txBody>
@@ -9138,6 +9096,548 @@
       </p:sp>
       <p:sp>
         <p:nvSpPr>
+          <p:cNvPr id="3" name="TextBox 2"/>
+          <p:cNvSpPr txBox="1"/>
+          <p:nvPr/>
+        </p:nvSpPr>
+        <p:spPr>
+          <a:xfrm>
+            <a:off x="685800" y="411480"/>
+            <a:ext cx="10820095" cy="914400"/>
+          </a:xfrm>
+          <a:prstGeom prst="rect">
+            <a:avLst/>
+          </a:prstGeom>
+          <a:noFill/>
+        </p:spPr>
+        <p:txBody>
+          <a:bodyPr wrap="square" lIns="0" rIns="0" tIns="0" bIns="0">
+            <a:spAutoFit/>
+          </a:bodyPr>
+          <a:lstStyle/>
+          <a:p>
+            <a:pPr algn="l">
+              <a:spcAft>
+                <a:spcPts val="200"/>
+              </a:spcAft>
+            </a:pPr>
+            <a:r>
+              <a:rPr sz="3200" b="1">
+                <a:solidFill>
+                  <a:srgbClr val="F2F4F8"/>
+                </a:solidFill>
+              </a:rPr>
+              <a:t>Trabalhos futuros</a:t>
+            </a:r>
+          </a:p>
+          <a:p>
+            <a:pPr algn="l">
+              <a:spcAft>
+                <a:spcPts val="0"/>
+              </a:spcAft>
+            </a:pPr>
+            <a:r>
+              <a:rPr sz="1500" b="0">
+                <a:solidFill>
+                  <a:srgbClr val="9FB3C8"/>
+                </a:solidFill>
+              </a:rPr>
+              <a:t>O que fica encaminhado</a:t>
+            </a:r>
+          </a:p>
+        </p:txBody>
+      </p:sp>
+      <p:sp>
+        <p:nvSpPr>
+          <p:cNvPr id="4" name="Rectangle 3"/>
+          <p:cNvSpPr/>
+          <p:nvPr/>
+        </p:nvSpPr>
+        <p:spPr>
+          <a:xfrm>
+            <a:off x="685800" y="1298448"/>
+            <a:ext cx="1371600" cy="38100"/>
+          </a:xfrm>
+          <a:prstGeom prst="rect">
+            <a:avLst/>
+          </a:prstGeom>
+          <a:solidFill>
+            <a:srgbClr val="E2B714"/>
+          </a:solidFill>
+          <a:ln>
+            <a:noFill/>
+          </a:ln>
+          <a:effectLst/>
+        </p:spPr>
+        <p:style>
+          <a:lnRef idx="1">
+            <a:schemeClr val="accent1"/>
+          </a:lnRef>
+          <a:fillRef idx="3">
+            <a:schemeClr val="accent1"/>
+          </a:fillRef>
+          <a:effectRef idx="2">
+            <a:schemeClr val="accent1"/>
+          </a:effectRef>
+          <a:fontRef idx="minor">
+            <a:schemeClr val="lt1"/>
+          </a:fontRef>
+        </p:style>
+        <p:txBody>
+          <a:bodyPr rtlCol="0" anchor="ctr"/>
+          <a:lstStyle/>
+          <a:p>
+            <a:pPr algn="ctr"/>
+          </a:p>
+        </p:txBody>
+      </p:sp>
+      <p:sp>
+        <p:nvSpPr>
+          <p:cNvPr id="5" name="Rounded Rectangle 4"/>
+          <p:cNvSpPr/>
+          <p:nvPr/>
+        </p:nvSpPr>
+        <p:spPr>
+          <a:xfrm>
+            <a:off x="685800" y="1783080"/>
+            <a:ext cx="3429000" cy="2834640"/>
+          </a:xfrm>
+          <a:prstGeom prst="roundRect">
+            <a:avLst>
+              <a:gd name="adj" fmla="val 6000"/>
+            </a:avLst>
+          </a:prstGeom>
+          <a:solidFill>
+            <a:srgbClr val="172740"/>
+          </a:solidFill>
+          <a:ln w="15875">
+            <a:solidFill>
+              <a:srgbClr val="E94560"/>
+            </a:solidFill>
+          </a:ln>
+          <a:effectLst/>
+        </p:spPr>
+        <p:style>
+          <a:lnRef idx="1">
+            <a:schemeClr val="accent1"/>
+          </a:lnRef>
+          <a:fillRef idx="3">
+            <a:schemeClr val="accent1"/>
+          </a:fillRef>
+          <a:effectRef idx="2">
+            <a:schemeClr val="accent1"/>
+          </a:effectRef>
+          <a:fontRef idx="minor">
+            <a:schemeClr val="lt1"/>
+          </a:fontRef>
+        </p:style>
+        <p:txBody>
+          <a:bodyPr rtlCol="0" anchor="t" wrap="square" lIns="201168" rIns="201168" tIns="164592" bIns="164592"/>
+          <a:lstStyle/>
+          <a:p>
+            <a:pPr algn="l">
+              <a:spcAft>
+                <a:spcPts val="600"/>
+              </a:spcAft>
+            </a:pPr>
+            <a:r>
+              <a:rPr sz="1700" b="1">
+                <a:solidFill>
+                  <a:srgbClr val="E94560"/>
+                </a:solidFill>
+              </a:rPr>
+              <a:t>Hardware</a:t>
+            </a:r>
+          </a:p>
+          <a:p>
+            <a:pPr algn="l">
+              <a:spcAft>
+                <a:spcPts val="400"/>
+              </a:spcAft>
+            </a:pPr>
+            <a:r>
+              <a:rPr sz="1300" b="0">
+                <a:solidFill>
+                  <a:srgbClr val="D6DEE8"/>
+                </a:solidFill>
+              </a:rPr>
+              <a:t>Concluir as 64 casas do tabuleiro com chapa de espessura adequada</a:t>
+            </a:r>
+          </a:p>
+          <a:p>
+            <a:pPr algn="l">
+              <a:spcAft>
+                <a:spcPts val="400"/>
+              </a:spcAft>
+            </a:pPr>
+            <a:r>
+              <a:rPr sz="1300" b="0">
+                <a:solidFill>
+                  <a:srgbClr val="D6DEE8"/>
+                </a:solidFill>
+              </a:rPr>
+              <a:t>Medir a taxa de acerto da detecção e exercitar o debouncing com esbarrões reais (RNF3)</a:t>
+            </a:r>
+          </a:p>
+          <a:p>
+            <a:pPr algn="l">
+              <a:spcAft>
+                <a:spcPts val="400"/>
+              </a:spcAft>
+            </a:pPr>
+            <a:r>
+              <a:rPr sz="1300" b="0">
+                <a:solidFill>
+                  <a:srgbClr val="D6DEE8"/>
+                </a:solidFill>
+              </a:rPr>
+              <a:t>Integrar o display 16×2 por I²C ao caminho principal</a:t>
+            </a:r>
+          </a:p>
+        </p:txBody>
+      </p:sp>
+      <p:sp>
+        <p:nvSpPr>
+          <p:cNvPr id="6" name="Rounded Rectangle 5"/>
+          <p:cNvSpPr/>
+          <p:nvPr/>
+        </p:nvSpPr>
+        <p:spPr>
+          <a:xfrm>
+            <a:off x="4480560" y="1783080"/>
+            <a:ext cx="3429000" cy="2834640"/>
+          </a:xfrm>
+          <a:prstGeom prst="roundRect">
+            <a:avLst>
+              <a:gd name="adj" fmla="val 6000"/>
+            </a:avLst>
+          </a:prstGeom>
+          <a:solidFill>
+            <a:srgbClr val="172740"/>
+          </a:solidFill>
+          <a:ln w="15875">
+            <a:solidFill>
+              <a:srgbClr val="E2B714"/>
+            </a:solidFill>
+          </a:ln>
+          <a:effectLst/>
+        </p:spPr>
+        <p:style>
+          <a:lnRef idx="1">
+            <a:schemeClr val="accent1"/>
+          </a:lnRef>
+          <a:fillRef idx="3">
+            <a:schemeClr val="accent1"/>
+          </a:fillRef>
+          <a:effectRef idx="2">
+            <a:schemeClr val="accent1"/>
+          </a:effectRef>
+          <a:fontRef idx="minor">
+            <a:schemeClr val="lt1"/>
+          </a:fontRef>
+        </p:style>
+        <p:txBody>
+          <a:bodyPr rtlCol="0" anchor="t" wrap="square" lIns="201168" rIns="201168" tIns="164592" bIns="164592"/>
+          <a:lstStyle/>
+          <a:p>
+            <a:pPr algn="l">
+              <a:spcAft>
+                <a:spcPts val="600"/>
+              </a:spcAft>
+            </a:pPr>
+            <a:r>
+              <a:rPr sz="1700" b="1">
+                <a:solidFill>
+                  <a:srgbClr val="E2B714"/>
+                </a:solidFill>
+              </a:rPr>
+              <a:t>Medição</a:t>
+            </a:r>
+          </a:p>
+          <a:p>
+            <a:pPr algn="l">
+              <a:spcAft>
+                <a:spcPts val="400"/>
+              </a:spcAft>
+            </a:pPr>
+            <a:r>
+              <a:rPr sz="1300" b="0">
+                <a:solidFill>
+                  <a:srgbClr val="D6DEE8"/>
+                </a:solidFill>
+              </a:rPr>
+              <a:t>Instrumentar o caminho completo — sensor ou tecla até o quadro renderizado — no próprio Raspberry Pi</a:t>
+            </a:r>
+          </a:p>
+          <a:p>
+            <a:pPr algn="l">
+              <a:spcAft>
+                <a:spcPts val="400"/>
+              </a:spcAft>
+            </a:pPr>
+            <a:r>
+              <a:rPr sz="1300" b="0">
+                <a:solidFill>
+                  <a:srgbClr val="D6DEE8"/>
+                </a:solidFill>
+              </a:rPr>
+              <a:t>Fechar as evidências de RNF1 (&lt; 200 ms) e RNF2 (&lt; 100 ms)</a:t>
+            </a:r>
+          </a:p>
+          <a:p>
+            <a:pPr algn="l">
+              <a:spcAft>
+                <a:spcPts val="400"/>
+              </a:spcAft>
+            </a:pPr>
+            <a:r>
+              <a:rPr sz="1300" b="0">
+                <a:solidFill>
+                  <a:srgbClr val="D6DEE8"/>
+                </a:solidFill>
+              </a:rPr>
+              <a:t>Teste de aceitação: partidas completas até o xeque-mate</a:t>
+            </a:r>
+          </a:p>
+        </p:txBody>
+      </p:sp>
+      <p:sp>
+        <p:nvSpPr>
+          <p:cNvPr id="7" name="Rounded Rectangle 6"/>
+          <p:cNvSpPr/>
+          <p:nvPr/>
+        </p:nvSpPr>
+        <p:spPr>
+          <a:xfrm>
+            <a:off x="8275320" y="1783080"/>
+            <a:ext cx="3429000" cy="2834640"/>
+          </a:xfrm>
+          <a:prstGeom prst="roundRect">
+            <a:avLst>
+              <a:gd name="adj" fmla="val 6000"/>
+            </a:avLst>
+          </a:prstGeom>
+          <a:solidFill>
+            <a:srgbClr val="172740"/>
+          </a:solidFill>
+          <a:ln w="15875">
+            <a:solidFill>
+              <a:srgbClr val="4CC38A"/>
+            </a:solidFill>
+          </a:ln>
+          <a:effectLst/>
+        </p:spPr>
+        <p:style>
+          <a:lnRef idx="1">
+            <a:schemeClr val="accent1"/>
+          </a:lnRef>
+          <a:fillRef idx="3">
+            <a:schemeClr val="accent1"/>
+          </a:fillRef>
+          <a:effectRef idx="2">
+            <a:schemeClr val="accent1"/>
+          </a:effectRef>
+          <a:fontRef idx="minor">
+            <a:schemeClr val="lt1"/>
+          </a:fontRef>
+        </p:style>
+        <p:txBody>
+          <a:bodyPr rtlCol="0" anchor="t" wrap="square" lIns="201168" rIns="201168" tIns="164592" bIns="164592"/>
+          <a:lstStyle/>
+          <a:p>
+            <a:pPr algn="l">
+              <a:spcAft>
+                <a:spcPts val="600"/>
+              </a:spcAft>
+            </a:pPr>
+            <a:r>
+              <a:rPr sz="1700" b="1">
+                <a:solidFill>
+                  <a:srgbClr val="4CC38A"/>
+                </a:solidFill>
+              </a:rPr>
+              <a:t>Software</a:t>
+            </a:r>
+          </a:p>
+          <a:p>
+            <a:pPr algn="l">
+              <a:spcAft>
+                <a:spcPts val="400"/>
+              </a:spcAft>
+            </a:pPr>
+            <a:r>
+              <a:rPr sz="1300" b="0">
+                <a:solidFill>
+                  <a:srgbClr val="D6DEE8"/>
+                </a:solidFill>
+              </a:rPr>
+              <a:t>Envio de lances ao Lichess fora do loop principal (hoje é POST síncrono)</a:t>
+            </a:r>
+          </a:p>
+          <a:p>
+            <a:pPr algn="l">
+              <a:spcAft>
+                <a:spcPts val="400"/>
+              </a:spcAft>
+            </a:pPr>
+            <a:r>
+              <a:rPr sz="1300" b="0">
+                <a:solidFill>
+                  <a:srgbClr val="D6DEE8"/>
+                </a:solidFill>
+              </a:rPr>
+              <a:t>Reconexão automática do stream e reconstrução do estado após takeback</a:t>
+            </a:r>
+          </a:p>
+          <a:p>
+            <a:pPr algn="l">
+              <a:spcAft>
+                <a:spcPts val="400"/>
+              </a:spcAft>
+            </a:pPr>
+            <a:r>
+              <a:rPr sz="1300" b="0">
+                <a:solidFill>
+                  <a:srgbClr val="D6DEE8"/>
+                </a:solidFill>
+              </a:rPr>
+              <a:t>Diálogo de promoção (hoje promove sempre para dama)</a:t>
+            </a:r>
+          </a:p>
+          <a:p>
+            <a:pPr algn="l">
+              <a:spcAft>
+                <a:spcPts val="400"/>
+              </a:spcAft>
+            </a:pPr>
+            <a:r>
+              <a:rPr sz="1300" b="0">
+                <a:solidFill>
+                  <a:srgbClr val="D6DEE8"/>
+                </a:solidFill>
+              </a:rPr>
+              <a:t>Relógios da partida e suporte a variantes</a:t>
+            </a:r>
+          </a:p>
+        </p:txBody>
+      </p:sp>
+      <p:sp>
+        <p:nvSpPr>
+          <p:cNvPr id="8" name="TextBox 7"/>
+          <p:cNvSpPr txBox="1"/>
+          <p:nvPr/>
+        </p:nvSpPr>
+        <p:spPr>
+          <a:xfrm>
+            <a:off x="685800" y="4937760"/>
+            <a:ext cx="10820095" cy="1280160"/>
+          </a:xfrm>
+          <a:prstGeom prst="rect">
+            <a:avLst/>
+          </a:prstGeom>
+          <a:noFill/>
+        </p:spPr>
+        <p:txBody>
+          <a:bodyPr wrap="square" lIns="0" rIns="0" tIns="0" bIns="0">
+            <a:spAutoFit/>
+          </a:bodyPr>
+          <a:lstStyle/>
+          <a:p>
+            <a:pPr algn="l">
+              <a:spcAft>
+                <a:spcPts val="800"/>
+              </a:spcAft>
+            </a:pPr>
+            <a:r>
+              <a:rPr sz="1900" b="1">
+                <a:solidFill>
+                  <a:srgbClr val="F2F4F8"/>
+                </a:solidFill>
+              </a:rPr>
+              <a:t>Considerações finais</a:t>
+            </a:r>
+          </a:p>
+          <a:p>
+            <a:pPr algn="l">
+              <a:spcAft>
+                <a:spcPts val="0"/>
+              </a:spcAft>
+            </a:pPr>
+            <a:r>
+              <a:rPr sz="1500" b="0">
+                <a:solidFill>
+                  <a:srgbClr val="D6DEE8"/>
+                </a:solidFill>
+              </a:rPr>
+              <a:t>O sistema está jogável de ponta a ponta — contra o Stockfish e contra oponentes online — com toda a lógica de xadrez, a interface e a integração validadas por testes automatizados. A retirada automática de peças capturadas fechou o último atrito de usabilidade do teclado. O que separa o projeto do escopo original é a montagem física do tabuleiro, e a decisão de manter as camadas de entrada intercambiáveis foi o que permitiu que esse atraso não bloqueasse o resto.</a:t>
+            </a:r>
+          </a:p>
+        </p:txBody>
+      </p:sp>
+    </p:spTree>
+  </p:cSld>
+  <p:clrMapOvr>
+    <a:masterClrMapping/>
+  </p:clrMapOvr>
+</p:sld>
+</file>
+
+<file path=ppt/slides/slide17.xml><?xml version="1.0" encoding="utf-8"?>
+<p:sld xmlns:a="http://schemas.openxmlformats.org/drawingml/2006/main" xmlns:p="http://schemas.openxmlformats.org/presentationml/2006/main" xmlns:r="http://schemas.openxmlformats.org/officeDocument/2006/relationships">
+  <p:cSld>
+    <p:spTree>
+      <p:nvGrpSpPr>
+        <p:cNvPr id="1" name=""/>
+        <p:cNvGrpSpPr/>
+        <p:nvPr/>
+      </p:nvGrpSpPr>
+      <p:grpSpPr/>
+      <p:sp>
+        <p:nvSpPr>
+          <p:cNvPr id="2" name="Rectangle 1"/>
+          <p:cNvSpPr/>
+          <p:nvPr/>
+        </p:nvSpPr>
+        <p:spPr>
+          <a:xfrm>
+            <a:off x="0" y="0"/>
+            <a:ext cx="12191695" cy="6858000"/>
+          </a:xfrm>
+          <a:prstGeom prst="rect">
+            <a:avLst/>
+          </a:prstGeom>
+          <a:solidFill>
+            <a:srgbClr val="0F1B2D"/>
+          </a:solidFill>
+          <a:ln>
+            <a:noFill/>
+          </a:ln>
+          <a:effectLst/>
+        </p:spPr>
+        <p:style>
+          <a:lnRef idx="1">
+            <a:schemeClr val="accent1"/>
+          </a:lnRef>
+          <a:fillRef idx="3">
+            <a:schemeClr val="accent1"/>
+          </a:fillRef>
+          <a:effectRef idx="2">
+            <a:schemeClr val="accent1"/>
+          </a:effectRef>
+          <a:fontRef idx="minor">
+            <a:schemeClr val="lt1"/>
+          </a:fontRef>
+        </p:style>
+        <p:txBody>
+          <a:bodyPr rtlCol="0" anchor="ctr"/>
+          <a:lstStyle/>
+          <a:p>
+            <a:pPr algn="ctr"/>
+          </a:p>
+        </p:txBody>
+      </p:sp>
+      <p:sp>
+        <p:nvSpPr>
           <p:cNvPr id="3" name="Rectangle 2"/>
           <p:cNvSpPr/>
           <p:nvPr/>
@@ -11962,7 +12462,7 @@
         <p:spPr>
           <a:xfrm>
             <a:off x="685800" y="1828800"/>
-            <a:ext cx="5486400" cy="1234440"/>
+            <a:ext cx="5303520" cy="1234440"/>
           </a:xfrm>
           <a:prstGeom prst="roundRect">
             <a:avLst>
@@ -12054,8 +12554,8 @@
         </p:nvSpPr>
         <p:spPr>
           <a:xfrm>
-            <a:off x="685800" y="3291840"/>
-            <a:ext cx="5486400" cy="2423160"/>
+            <a:off x="685800" y="3246120"/>
+            <a:ext cx="5303520" cy="1051560"/>
           </a:xfrm>
           <a:prstGeom prst="roundRect">
             <a:avLst>
@@ -12063,6 +12563,99 @@
             </a:avLst>
           </a:prstGeom>
           <a:solidFill>
+            <a:srgbClr val="0A121F"/>
+          </a:solidFill>
+          <a:ln w="15875">
+            <a:solidFill>
+              <a:srgbClr val="2A4063"/>
+            </a:solidFill>
+          </a:ln>
+          <a:effectLst/>
+        </p:spPr>
+        <p:style>
+          <a:lnRef idx="1">
+            <a:schemeClr val="accent1"/>
+          </a:lnRef>
+          <a:fillRef idx="3">
+            <a:schemeClr val="accent1"/>
+          </a:fillRef>
+          <a:effectRef idx="2">
+            <a:schemeClr val="accent1"/>
+          </a:effectRef>
+          <a:fontRef idx="minor">
+            <a:schemeClr val="lt1"/>
+          </a:fontRef>
+        </p:style>
+        <p:txBody>
+          <a:bodyPr rtlCol="0" anchor="ctr" wrap="square" lIns="182880" rIns="182880" tIns="128016" bIns="128016"/>
+          <a:lstStyle/>
+          <a:p>
+            <a:pPr algn="l">
+              <a:spcAft>
+                <a:spcPts val="200"/>
+              </a:spcAft>
+            </a:pPr>
+            <a:r>
+              <a:rPr sz="1500" b="0">
+                <a:solidFill>
+                  <a:srgbClr val="E2B714"/>
+                </a:solidFill>
+                <a:latin typeface="Consolas"/>
+              </a:rPr>
+              <a:t>@sync|&lt;64 caracteres '0'/'1'&gt;       Python → C</a:t>
+            </a:r>
+          </a:p>
+          <a:p>
+            <a:pPr algn="l">
+              <a:spcAft>
+                <a:spcPts val="200"/>
+              </a:spcAft>
+            </a:pPr>
+            <a:r>
+              <a:rPr sz="1500" b="0">
+                <a:solidFill>
+                  <a:srgbClr val="D6DEE8"/>
+                </a:solidFill>
+                <a:latin typeface="Consolas"/>
+              </a:rPr>
+              <a:t/>
+            </a:r>
+          </a:p>
+          <a:p>
+            <a:pPr algn="l">
+              <a:spcAft>
+                <a:spcPts val="200"/>
+              </a:spcAft>
+            </a:pPr>
+            <a:r>
+              <a:rPr sz="1500" b="0">
+                <a:solidFill>
+                  <a:srgbClr val="9FB3C8"/>
+                </a:solidFill>
+                <a:latin typeface="Consolas"/>
+              </a:rPr>
+              <a:t>Espelho de ocupação, na ordem a1..h8</a:t>
+            </a:r>
+          </a:p>
+        </p:txBody>
+      </p:sp>
+      <p:sp>
+        <p:nvSpPr>
+          <p:cNvPr id="7" name="Rounded Rectangle 6"/>
+          <p:cNvSpPr/>
+          <p:nvPr/>
+        </p:nvSpPr>
+        <p:spPr>
+          <a:xfrm>
+            <a:off x="685800" y="4480560"/>
+            <a:ext cx="5303520" cy="1737360"/>
+          </a:xfrm>
+          <a:prstGeom prst="roundRect">
+            <a:avLst>
+              <a:gd name="adj" fmla="val 6000"/>
+            </a:avLst>
+          </a:prstGeom>
+          <a:solidFill>
             <a:srgbClr val="172740"/>
           </a:solidFill>
           <a:ln w="15875">
@@ -12149,48 +12742,18 @@
               <a:t>Roque curto  →  e1:0,g1:1  e depois  h1:0,f1:1</a:t>
             </a:r>
           </a:p>
-          <a:p>
-            <a:pPr algn="l">
-              <a:spcAft>
-                <a:spcPts val="400"/>
-              </a:spcAft>
-            </a:pPr>
-            <a:r>
-              <a:rPr sz="1300" b="0">
-                <a:solidFill>
-                  <a:srgbClr val="D6DEE8"/>
-                </a:solidFill>
-              </a:rPr>
-              <a:t/>
-            </a:r>
-          </a:p>
-          <a:p>
-            <a:pPr algn="l">
-              <a:spcAft>
-                <a:spcPts val="400"/>
-              </a:spcAft>
-            </a:pPr>
-            <a:r>
-              <a:rPr sz="1300" b="0">
-                <a:solidFill>
-                  <a:srgbClr val="D6DEE8"/>
-                </a:solidFill>
-              </a:rPr>
-              <a:t>O roque chega em duas etapas: rei primeiro, torre depois — como na mão do jogador sobre o tabuleiro.</a:t>
-            </a:r>
-          </a:p>
-        </p:txBody>
-      </p:sp>
-      <p:sp>
-        <p:nvSpPr>
-          <p:cNvPr id="7" name="Rounded Rectangle 6"/>
-          <p:cNvSpPr/>
-          <p:nvPr/>
-        </p:nvSpPr>
-        <p:spPr>
-          <a:xfrm>
-            <a:off x="6537960" y="1828800"/>
-            <a:ext cx="4937760" cy="1234440"/>
+        </p:txBody>
+      </p:sp>
+      <p:sp>
+        <p:nvSpPr>
+          <p:cNvPr id="8" name="Rounded Rectangle 7"/>
+          <p:cNvSpPr/>
+          <p:nvPr/>
+        </p:nvSpPr>
+        <p:spPr>
+          <a:xfrm>
+            <a:off x="6355080" y="1828800"/>
+            <a:ext cx="5120640" cy="1234440"/>
           </a:xfrm>
           <a:prstGeom prst="roundRect">
             <a:avLst>
@@ -12258,14 +12821,14 @@
       </p:sp>
       <p:sp>
         <p:nvSpPr>
-          <p:cNvPr id="8" name="Rounded Rectangle 7"/>
-          <p:cNvSpPr/>
-          <p:nvPr/>
-        </p:nvSpPr>
-        <p:spPr>
-          <a:xfrm>
-            <a:off x="6537960" y="3291840"/>
-            <a:ext cx="4937760" cy="2423160"/>
+          <p:cNvPr id="9" name="Rounded Rectangle 8"/>
+          <p:cNvSpPr/>
+          <p:nvPr/>
+        </p:nvSpPr>
+        <p:spPr>
+          <a:xfrm>
+            <a:off x="6355080" y="3246120"/>
+            <a:ext cx="5120640" cy="2971800"/>
           </a:xfrm>
           <a:prstGeom prst="roundRect">
             <a:avLst>
@@ -12356,14 +12919,44 @@
                   <a:srgbClr val="D6DEE8"/>
                 </a:solidFill>
               </a:rPr>
-              <a:t>Linhas @entry avisam a GUI do que está sendo digitado, para destacar origem e destinos legais.</a:t>
-            </a:r>
-          </a:p>
-        </p:txBody>
-      </p:sp>
-      <p:sp>
-        <p:nvSpPr>
-          <p:cNvPr id="9" name="TextBox 8"/>
+              <a:t>Linhas @entry avisam a GUI do que está sendo digitado.</a:t>
+            </a:r>
+          </a:p>
+          <a:p>
+            <a:pPr algn="l">
+              <a:spcAft>
+                <a:spcPts val="400"/>
+              </a:spcAft>
+            </a:pPr>
+            <a:r>
+              <a:rPr sz="1300" b="0">
+                <a:solidFill>
+                  <a:srgbClr val="D6DEE8"/>
+                </a:solidFill>
+              </a:rPr>
+              <a:t/>
+            </a:r>
+          </a:p>
+          <a:p>
+            <a:pPr algn="l">
+              <a:spcAft>
+                <a:spcPts val="400"/>
+              </a:spcAft>
+            </a:pPr>
+            <a:r>
+              <a:rPr sz="1300" b="0">
+                <a:solidFill>
+                  <a:srgbClr val="D6DEE8"/>
+                </a:solidFill>
+              </a:rPr>
+              <a:t>Canal de volta: a aplicação manda @sync com o espelho dela, e a camada C adota — peças capturadas pelo oponente saem sozinhas.</a:t>
+            </a:r>
+          </a:p>
+        </p:txBody>
+      </p:sp>
+      <p:sp>
+        <p:nvSpPr>
+          <p:cNvPr id="10" name="TextBox 9"/>
           <p:cNvSpPr txBox="1"/>
           <p:nvPr/>
         </p:nvSpPr>

</xml_diff>